<commit_message>
docs: slides-export chỉ giữ file slide thuyết trình
Co-Authored-By: Claude Sonnet 5.5 <noreply@anthropic.com>
Claude-Session: https://claude.ai/code/session_01WVcQLHfr6oY6SYZ4u3c34C
</commit_message>
<xml_diff>
--- a/slides-export/prm323_lab2_group6_slides.pptx
+++ b/slides-export/prm323_lab2_group6_slides.pptx
@@ -435,8 +435,7 @@
           <a:lstStyle/>
           <a:p>
             <a:r>
-              <a:rPr lang="vi" dirty="0"/>
-              <a:t>Em nói rõ mục nào đã đo và mục nào còn TODO. Với chữ thường cần tối thiểu 4.5 trên 1: on-surface trên surface đạt 17.22, on-primary trên primary đạt 5.86, error trên error-container đạt 5.14. Với control cần tối thiểu 3 trên 1: outline trên surface đạt 4.61, viền ô đề xuất đạt 4.76, còn viền thẻ chỉ 1.48 là ngoại lệ vì chỉ dùng để phân tách. Touch target từ 48 dp, chữ từ 14 sp, và không chỉ dùng màu để báo trạng thái. Ở 360 dp đã kiểm trong Figma: 21 frame 360 nhân 800, không có chữ dưới 14 sp. Ở 412 dp em chưa kiểm, nên nói rõ là chưa làm. Với màn rộng từ 600 dp, nhóm đặc tả NavigationRail và master-detail, nhưng mới chỉ là đặc tả. Bằng chứng là checklist trong design/design-decisions.md.</a:t>
+              <a:t>Em nói rõ mục nào đã đo và mục nào chưa. Chữ thường cần tối thiểu 4.5 trên 1: on-surface trên surface đạt 17.22, on-primary trên primary đạt 5.86, error trên error-container đạt 5.14. Control cần tối thiểu 3 trên 1: outline trên surface đạt 4.61, viền ô đề xuất đạt 4.76; viền thẻ 1.48 là ngoại lệ vì chỉ để phân tách. Touch target từ 48 dp. Em đã quét cả 25 màn trong Figma: không có chữ nào dưới 14 sp. Trạng thái luôn kèm chữ hoặc biểu tượng. Em chưa kiểm ở 412 dp, và màn rộng từ 600 dp mới chỉ là đặc tả NavigationRail và master-detail. Bằng chứng là checklist trong design/design-decisions.md.</a:t>
             </a:r>
           </a:p>
         </p:txBody>
@@ -494,8 +493,7 @@
           <a:lstStyle/>
           <a:p>
             <a:r>
-              <a:rPr lang="vi" dirty="0"/>
-              <a:t>Phần này em demo trực tiếp trong Figma, không dùng ảnh tĩnh. Ba flow bấm được từ điểm bắt đầu đến kết thúc và không có ngõ cụt; em đã kiểm bằng script rằng mọi màn của từng flow đều tới được từ điểm bắt đầu, và sẽ bấm trực tiếp khi demo. Hộp thoại Approve S12 và Discard S17 là overlay. Màn loading S8 AI matching dẫn tới kết quả là S9 Proposals hoặc S15 No match. Nút Back luôn quay đúng màn trước.</a:t>
+              <a:t>Phần này em demo trực tiếp trong Figma, không dùng ảnh tĩnh. Prototype có ba mươi lăm frame, ba flow bấm được từ điểm bắt đầu đến kết thúc và không có ngõ cụt; em đã kiểm bằng script rằng mọi frame đều tới được từ điểm bắt đầu. Hộp thoại Approve S12, Discard S17 và bỏ thành viên S24 là overlay. Màn loading S8 dẫn tới S9 Proposals hoặc S15 No match. Nút Back quay đúng màn trước.</a:t>
             </a:r>
           </a:p>
         </p:txBody>
@@ -553,8 +551,7 @@
           <a:lstStyle/>
           <a:p>
             <a:r>
-              <a:rPr lang="vi" dirty="0"/>
-              <a:t>Em trả lời được câu hỏi một dev Flutter lạ dựng màn S12 từ handoff thế nào. Mỗi màn trong hai mươi mốt màn có sáu mục: layout, components, states, interactions, navigation và constraints. Có hai bảng: token sang Flutter gồm ColorScheme, TextTheme và hằng số; component sang widget như FilledButton, TextFormField, NavigationBar, AlertDialog. Màn rộng từ 600 dp cũng được mô tả trong handoff. Về hạn chế, phần AI ghép nhóm chỉ là thiết kế giao diện với dữ liệu mẫu và không có mô hình thật; các lỗi kích thước từ Stitch đã sửa trong Figma, hiện cả 21 frame đều 360 nhân 800. Em xin cảm ơn và mời mọi người đặt câu hỏi. Bằng chứng: handoff/flutter-handoff.md và GitHub.</a:t>
+              <a:t>Em trả lời được câu hỏi một dev Flutter lạ dựng màn S12 từ handoff thế nào. Mỗi màn trong hai mươi lăm màn có sáu mục: layout, components, states, interactions, navigation và constraints. Có hai bảng: token sang Flutter gồm ColorScheme, TextTheme và hằng số; component sang widget như FilledButton, TextFormField, NavigationBar, AlertDialog. Màn rộng từ 600 dp cũng được mô tả trong handoff. Về hạn chế, phần AI ghép nhóm chỉ là thiết kế giao diện với dữ liệu mẫu và không có mô hình thật; các lỗi kích thước từ Stitch đã sửa trong Figma, hiện cả 25 màn đều 360 nhân 800. Em xin cảm ơn và mời mọi người đặt câu hỏi. Bằng chứng: handoff/flutter-handoff.md và GitHub.</a:t>
             </a:r>
           </a:p>
         </p:txBody>
@@ -612,8 +609,7 @@
           <a:lstStyle/>
           <a:p>
             <a:r>
-              <a:rPr lang="vi" dirty="0"/>
-              <a:t>Persona của nhóm là Cô Lan, 38 tuổi, giảng viên và mentor phụ trách ba lớp EXE, khoảng bốn mươi sinh viên mỗi lớp. Nỗi đau chính là nhiều bạn chưa có nhóm, ghép tay bằng Excel và tin nhắn thì khó nhớ ngành, kỹ năng và lịch rảnh, ghép vội thì nhóm lệch ngành và chỉ lộ ra giữa kỳ, trong khi mentor chỉ có vài phút mỗi lần. Em nhấn mạnh thiết bị: dùng một tay, vài phút giữa các tiết, wifi trường chập chờn. Vấn đề gói trong một câu: mentor có sinh viên chưa có nhóm và nhóm còn thiếu chuyên môn, nhưng phải ghép thủ công nên mất thời gian và dễ lệch ngành. Ba tiêu chí thành công là duyệt xong gợi ý AI cho một lớp dưới năm phút, mọi nhóm sau duyệt có bốn đến sáu người và ít nhất ba ngành, và thêm hoặc đổi một thành viên rồi duyệt dưới sáu mươi giây. Em nói thẳng: persona là giả định của nhóm, chưa kiểm chứng với người dùng thật.</a:t>
+              <a:t>Persona của nhóm là Cô Lan, 38 tuổi, mentor phụ trách ba lớp EXE, khoảng bốn mươi sinh viên mỗi lớp. Vấn đề: ghép nhóm bằng Excel và tin nhắn thì tốn thời gian và dễ lệch ngành. Luật nhóm do chủ dự án đưa ra: mỗi nhóm từ năm đến sáu người, ghép theo ngành SE, AI, GD, MKT. Em nhấn mạnh thiết bị: dùng một tay, vài phút giữa các tiết. Ba tiêu chí thành công: duyệt gợi ý cho một lớp dưới năm phút, mọi nhóm sau duyệt có năm đến sáu người và ít nhất ba ngành, đổi một thành viên rồi duyệt dưới sáu mươi giây. Em nói thẳng: persona là giả định của nhóm, chưa kiểm chứng với người dùng thật.</a:t>
             </a:r>
           </a:p>
         </p:txBody>
@@ -671,8 +667,7 @@
           <a:lstStyle/>
           <a:p>
             <a:r>
-              <a:rPr lang="vi" dirty="0"/>
-              <a:t>Ứng dụng có hai mươi mốt màn hình từ S1 đến S21 và thanh điều hướng ba tab: Classes, Proposals, Profile. Ba tab đủ vì Cô Lan chỉ có ba việc chính: chọn lớp, duyệt đề xuất, xem hồ sơ. Từ Classes, S2 dẫn tới Class detail S3, rồi tới No team S4, Need members S5 và Student detail S7. Từ Proposals, S9 dẫn tới Proposal detail S10, rồi Add member S11, và kết thúc ở hộp thoại Approve S12 hoặc Discard S17. Mỗi màn thuộc ít nhất một flow, riêng S6 Profile là tab gốc; S19 đến S21 là đường lỗi và nhánh ghép tay. Bằng chứng nằm trong ux/user-flow.md và Figma Page 01.</a:t>
+              <a:t>Ứng dụng có hai mươi lăm màn hình từ S1 đến S25 và thanh điều hướng ba tab: Classes, Proposals, Profile. Ba tab đủ vì Cô Lan chỉ có ba việc chính: chọn lớp, duyệt đề xuất, xem hồ sơ. Từ Classes, S2 dẫn tới Class detail S3, rồi tới No team S4, Need members S5 và Student detail S7. Từ Proposals, S9 dẫn tới Proposal detail S10, rồi Add member S11, và kết thúc ở hộp thoại Approve S12 hoặc Discard S17. Mỗi màn thuộc ít nhất một flow, riêng S6 Profile là tab gốc; S19 đến S21 là đường lỗi và nhánh ghép tay. Bốn màn mới S22 đến S25 là nhập danh sách lớp, kết quả nhập, hộp thoại bỏ thành viên và chặn duyệt khi nhóm dưới năm người. Bằng chứng nằm trong ux/user-flow.md và Figma Page 01.</a:t>
             </a:r>
           </a:p>
         </p:txBody>
@@ -730,8 +725,7 @@
           <a:lstStyle/>
           <a:p>
             <a:r>
-              <a:rPr lang="vi" dirty="0"/>
-              <a:t>Em kể một flow từ đầu đến cuối và chỉ ra đường lỗi cùng cách phục hồi. Flow A là duyệt gợi ý AI cho một lớp; lỗi gồm email sai, hiện ở S19, và mất mạng khi AI chạy, phục hồi bằng màn S18 với nút Try again. Flow B là thêm thành viên vào đề xuất; lỗi là vượt sáu người, hiện ở S13 với thông báo Max 6 members. Flow C là khi AI không ghép được và mentor ghép tay; lỗi là sinh viên đã có nhóm bị khóa ở S16, tìm không ra sinh viên ở S21, và mentor có thể hủy đề xuất bằng Discard ở S17. Bảng flow tới màn có trong user-flow.md. Ảnh flow nằm ở assets/flows.</a:t>
+              <a:t>Em kể từng flow và chỉ ra đường lỗi cùng cách phục hồi. Flow A là duyệt gợi ý AI cho một lớp; lỗi gồm email sai ở S19 và mất mạng khi AI chạy, phục hồi bằng S18 với nút Try again; nhánh nhập danh sách lớp là S22 và S23. Flow B là thêm hoặc bỏ thành viên; lỗi là vượt sáu người ở S13 với thông báo Max 6 members, và dưới năm người thì S25 chặn nút Approve; bỏ thành viên có hộp thoại xác nhận S24. Flow C là khi AI không ghép được và mentor ghép tay; lỗi là sinh viên đã có nhóm bị khóa ở S16, tìm không ra ở S21, và mentor có thể hủy đề xuất bằng Discard ở S17. Ảnh flow nằm ở assets/flows.</a:t>
             </a:r>
           </a:p>
         </p:txBody>
@@ -794,8 +788,7 @@
           <a:lstStyle/>
           <a:p>
             <a:r>
-              <a:rPr lang="vi" dirty="0"/>
-              <a:t>Prompt gửi cho Stitch gồm năm phần: người dùng là mentor, tác vụ là duyệt gợi ý AI, nền tảng là Android 360 nhân 800 với Material 3, ràng buộc gồm chữ từ 14 sp trở lên, một nút chính mỗi màn và không dùng từ cấm, và phong cách lấy từ DESIGN.md. Lần đầu, R0, theo hướng sinh viên, ra bốn màn và có chữ nội bộ như Lineup hay Roster. Sau đó nhóm đổi sang hướng mentor, R9, gồm ba prompt, mỗi prompt sáu frame, tổng mười tám frame rồi xuất sang Figma. Sau khi đối chiếu flow, em thấy thiếu ba trạng thái nên chạy thêm R10 với ba frame S19 đến S21, thành hai mươi mốt màn. Stitch chỉ ra khoảng sáu frame mỗi lần nên phải chia ba prompt. Hai ảnh trên slide là màn Discover của bản R0 hướng sinh viên ở bên trái, và màn Proposals của bản R9 hướng mentor ở bên phải, đều lấy từ thư mục Stitch. Prompt nguyên văn ở ai/stitch-prompts-r9.md và ai/ai-design-log.md mục 3.</a:t>
+              <a:t>Prompt gửi cho Stitch gồm năm phần: người dùng là mentor, tác vụ là duyệt gợi ý AI, nền tảng là Android 360 nhân 800, ràng buộc gồm chữ từ 14 sp, một nút chính mỗi màn và không dùng từ cấm, và phong cách lấy từ DESIGN.md. Lần đầu, R0, theo hướng sinh viên, ra bốn màn và có chữ nội bộ như Lineup hay Roster. Sau đó nhóm đổi sang hướng mentor: R9 gồm ba prompt, mười tám frame, và R10 thêm ba frame S19 đến S21, thành hai mươi mốt màn xuất sang Figma. Bốn màn S22 đến S25 không qua Stitch: nhóm dựng thẳng trong Figma từ các màn có sẵn, nên kế thừa Variables và text style. Hai ảnh trên slide là màn Discover của R0 bên trái và màn Proposals của R9 bên phải. Prompt nguyên văn ở ai/stitch-prompts-r9.md và ai/ai-design-log.md mục 3.</a:t>
             </a:r>
           </a:p>
         </p:txBody>
@@ -912,8 +905,7 @@
           <a:lstStyle/>
           <a:p>
             <a:r>
-              <a:rPr lang="vi" dirty="0"/>
-              <a:t>Em chuẩn bị trả lời câu hỏi: AI đề xuất nào bạn đã từ chối và vì sao. Nhóm giữ nguyên tắc AI chỉ đề xuất, mentor duyệt, với nhãn mức phù hợp và lý do ngắn. Nhóm sửa bằng cách bỏ chú thích dưới ô vai trò vì đè chữ ở 360 dp. Nhóm từ chối dùng cam FPT F37021 cho nút vì chữ trắng chỉ đạt 2.9 trên 1, màu này chỉ dùng cho logo. Nhóm cũng bỏ màu xanh dương, bỏ trường MSSV và email edu. Mỗi quyết định gắn với một thay đổi trong Figma, ví dụ S4 và S17 được sửa, S13 đổi thành Tutor Match 6 of 6. Bằng chứng: design/design-decisions.md và ai/ai-design-log.md mục 6.</a:t>
+              <a:t>Em chuẩn bị trả lời câu hỏi: AI đề xuất nào bạn đã từ chối và vì sao. Nhóm giữ nguyên tắc AI chỉ đề xuất, mentor duyệt. Nhóm sửa bằng cách bỏ chú thích đè chữ ở 360 dp. Nhóm từ chối cam FPT F37021 cho nút vì chữ trắng chỉ đạt 2.9 trên 1; màu này chỉ dùng cho logo. Nhóm cũng bỏ tông xanh dương, trường MSSV và email edu. Ngày 14 tháng 10 nhóm bổ sung bốn màn theo yêu cầu nghiệp vụ: nhập lớp, bỏ thành viên, chặn duyệt khi dưới năm người. Bằng chứng: design/design-decisions.md và ai/ai-design-log.md mục 6.</a:t>
             </a:r>
           </a:p>
         </p:txBody>
@@ -972,7 +964,7 @@
           <a:p>
             <a:r>
               <a:rPr lang="vi" dirty="0"/>
-              <a:t>Em chỉ ra phân cấp thị giác: tiêu đề, danh sách, rồi nút chính. Wireframe thấp ở Figma Page 02 được đặt cạnh hai mươi mốt màn final ở Page 03, kích thước 360 nhân 800. Mỗi màn có một nút chính, và hàng ngành cao 40 hoặc 48 dp làm điểm nhấn. Các state gồm loading ở S8, empty ở S14 All matched, error ở S13 và S18, dialog ở S12 và S17. Ảnh trên slide chụp từ Figma: S10 dạng wireframe xám ở bên trái và Final UI ở bên phải. Loading S8 và lỗi S13 em mở trực tiếp trong Page 03.</a:t>
+              <a:t>Em chỉ ra phân cấp thị giác: tiêu đề, danh sách, rồi nút chính. Wireframe thấp ở Figma Page 02 được đặt cạnh hai mươi lăm màn final ở Page 03, kích thước 360 nhân 800. Mỗi màn có một nút chính, và hàng ngành cao 40 hoặc 48 dp làm điểm nhấn. Các state gồm loading ở S8, empty ở S14 All matched, error ở S13 và S18, dialog ở S12 và S17. Ảnh trên slide chụp từ Figma: S10 dạng wireframe xám ở bên trái và Final UI ở bên phải. Loading S8 và lỗi S13 em mở trực tiếp trong Page 03.</a:t>
             </a:r>
           </a:p>
         </p:txBody>
@@ -1076,7 +1068,7 @@
             <a:avLst/>
           </a:prstGeom>
           <a:solidFill>
-            <a:schemeClr val="accent1"/>
+            <a:srgbClr val="1A56C8"/>
           </a:solidFill>
           <a:ln>
             <a:noFill/>
@@ -1098,7 +1090,7 @@
             <a:avLst/>
           </a:prstGeom>
           <a:solidFill>
-            <a:schemeClr val="accent3"/>
+            <a:srgbClr val="D0D4DA"/>
           </a:solidFill>
           <a:ln>
             <a:noFill/>
@@ -1120,7 +1112,7 @@
             <a:avLst/>
           </a:prstGeom>
           <a:solidFill>
-            <a:schemeClr val="accent2"/>
+            <a:srgbClr val="E1E4E8"/>
           </a:solidFill>
           <a:ln>
             <a:noFill/>
@@ -1142,7 +1134,7 @@
             <a:avLst/>
           </a:prstGeom>
           <a:solidFill>
-            <a:schemeClr val="accent5"/>
+            <a:srgbClr val="F0F2F4"/>
           </a:solidFill>
           <a:ln>
             <a:noFill/>
@@ -1164,7 +1156,7 @@
             <a:avLst/>
           </a:prstGeom>
           <a:solidFill>
-            <a:schemeClr val="accent1"/>
+            <a:srgbClr val="1A56C8"/>
           </a:solidFill>
           <a:ln>
             <a:noFill/>
@@ -1186,7 +1178,7 @@
             <a:avLst/>
           </a:prstGeom>
           <a:solidFill>
-            <a:schemeClr val="accent3"/>
+            <a:srgbClr val="D0D4DA"/>
           </a:solidFill>
           <a:ln>
             <a:noFill/>
@@ -1208,7 +1200,7 @@
             <a:avLst/>
           </a:prstGeom>
           <a:solidFill>
-            <a:schemeClr val="accent2"/>
+            <a:srgbClr val="E1E4E8"/>
           </a:solidFill>
           <a:ln>
             <a:noFill/>
@@ -1230,7 +1222,7 @@
             <a:avLst/>
           </a:prstGeom>
           <a:solidFill>
-            <a:schemeClr val="accent5"/>
+            <a:srgbClr val="F0F2F4"/>
           </a:solidFill>
           <a:ln>
             <a:noFill/>
@@ -1532,7 +1524,7 @@
             <a:avLst/>
           </a:prstGeom>
           <a:solidFill>
-            <a:schemeClr val="accent1"/>
+            <a:srgbClr val="1A56C8"/>
           </a:solidFill>
           <a:ln>
             <a:noFill/>
@@ -1554,7 +1546,7 @@
             <a:avLst/>
           </a:prstGeom>
           <a:solidFill>
-            <a:schemeClr val="accent3"/>
+            <a:srgbClr val="D0D4DA"/>
           </a:solidFill>
           <a:ln>
             <a:noFill/>
@@ -1576,7 +1568,7 @@
             <a:avLst/>
           </a:prstGeom>
           <a:solidFill>
-            <a:schemeClr val="accent2"/>
+            <a:srgbClr val="E1E4E8"/>
           </a:solidFill>
           <a:ln>
             <a:noFill/>
@@ -1598,7 +1590,7 @@
             <a:avLst/>
           </a:prstGeom>
           <a:solidFill>
-            <a:schemeClr val="accent5"/>
+            <a:srgbClr val="F0F2F4"/>
           </a:solidFill>
           <a:ln>
             <a:noFill/>
@@ -1754,7 +1746,7 @@
             <a:avLst/>
           </a:prstGeom>
           <a:solidFill>
-            <a:schemeClr val="accent1"/>
+            <a:srgbClr val="1A56C8"/>
           </a:solidFill>
           <a:ln>
             <a:noFill/>
@@ -1776,7 +1768,7 @@
             <a:avLst/>
           </a:prstGeom>
           <a:solidFill>
-            <a:schemeClr val="accent3"/>
+            <a:srgbClr val="D0D4DA"/>
           </a:solidFill>
           <a:ln>
             <a:noFill/>
@@ -1798,7 +1790,7 @@
             <a:avLst/>
           </a:prstGeom>
           <a:solidFill>
-            <a:schemeClr val="accent2"/>
+            <a:srgbClr val="E1E4E8"/>
           </a:solidFill>
           <a:ln>
             <a:noFill/>
@@ -1820,7 +1812,7 @@
             <a:avLst/>
           </a:prstGeom>
           <a:solidFill>
-            <a:schemeClr val="accent5"/>
+            <a:srgbClr val="F0F2F4"/>
           </a:solidFill>
           <a:ln>
             <a:noFill/>
@@ -1842,7 +1834,7 @@
             <a:avLst/>
           </a:prstGeom>
           <a:solidFill>
-            <a:schemeClr val="accent1"/>
+            <a:srgbClr val="1A56C8"/>
           </a:solidFill>
           <a:ln>
             <a:noFill/>
@@ -1864,7 +1856,7 @@
             <a:avLst/>
           </a:prstGeom>
           <a:solidFill>
-            <a:srgbClr val="FBBD06"/>
+            <a:srgbClr val="F1F3F4"/>
           </a:solidFill>
           <a:ln>
             <a:noFill/>
@@ -1886,7 +1878,7 @@
             <a:avLst/>
           </a:prstGeom>
           <a:solidFill>
-            <a:schemeClr val="accent3"/>
+            <a:srgbClr val="E3E6EA"/>
           </a:solidFill>
           <a:ln>
             <a:noFill/>
@@ -1908,7 +1900,7 @@
             <a:avLst/>
           </a:prstGeom>
           <a:solidFill>
-            <a:schemeClr val="accent5"/>
+            <a:srgbClr val="D0D4DA"/>
           </a:solidFill>
           <a:ln>
             <a:noFill/>
@@ -2597,8 +2589,8 @@
           </p:nvSpPr>
           <p:spPr>
             <a:xfrm>
-              <a:off x="939800" y="5384800"/>
-              <a:ext cx="8128000" cy="492633"/>
+              <a:off x="939800" y="5300000"/>
+              <a:ext cx="9500000" cy="492633"/>
             </a:xfrm>
             <a:prstGeom prst="rect">
               <a:avLst/>
@@ -2614,32 +2606,22 @@
             </a:bodyPr>
             <a:lstStyle/>
             <a:p>
-              <a:pPr algn="l">
+              <a:pPr marL="0" indent="0" algn="l">
                 <a:lnSpc>
-                  <a:spcPts val="1800"/>
+                  <a:spcPts val="2160"/>
                 </a:lnSpc>
+                <a:buNone/>
               </a:pPr>
               <a:r>
-                <a:rPr lang="vi" sz="1350" dirty="0">
+                <a:rPr lang="vi" sz="1600" dirty="0">
                   <a:solidFill>
-                    <a:schemeClr val="accent6"/>
+                    <a:srgbClr val="1C1B18"/>
                   </a:solidFill>
                   <a:latin typeface="+mn-lt"/>
                   <a:ea typeface="+mn-ea"/>
                   <a:cs typeface="+mn-cs"/>
                 </a:rPr>
-                <a:t>AI gợi ý ghép sinh viên chưa có nhóm vào nhóm đang thiếu 1-2 thành viên </a:t>
-              </a:r>
-              <a:r>
-                <a:rPr lang="vi" sz="1350" dirty="0">
-                  <a:solidFill>
-                    <a:schemeClr val="accent6"/>
-                  </a:solidFill>
-                  <a:latin typeface="+mn-lt"/>
-                  <a:ea typeface="+mn-ea"/>
-                  <a:cs typeface="+mn-cs"/>
-                </a:rPr>
-                <a:t>chuyên môn; mentor duyệt</a:t>
+                <a:t>Ghép sinh viên chưa có nhóm vào nhóm còn thiếu người, theo ngành</a:t>
               </a:r>
             </a:p>
           </p:txBody>
@@ -2652,8 +2634,8 @@
           </p:nvSpPr>
           <p:spPr>
             <a:xfrm>
-              <a:off x="939800" y="5918200"/>
-              <a:ext cx="8128000" cy="264033"/>
+              <a:off x="939800" y="5700000"/>
+              <a:ext cx="9500000" cy="264033"/>
             </a:xfrm>
             <a:prstGeom prst="rect">
               <a:avLst/>
@@ -2669,17 +2651,22 @@
             </a:bodyPr>
             <a:lstStyle/>
             <a:p>
-              <a:pPr algn="l"/>
+              <a:pPr marL="0" indent="0" algn="l">
+                <a:lnSpc>
+                  <a:spcPts val="2160"/>
+                </a:lnSpc>
+                <a:buNone/>
+              </a:pPr>
               <a:r>
-                <a:rPr lang="vi" sz="1350" dirty="0">
+                <a:rPr lang="vi" sz="1600" dirty="0">
                   <a:solidFill>
-                    <a:schemeClr val="accent6"/>
+                    <a:srgbClr val="1C1B18"/>
                   </a:solidFill>
                   <a:latin typeface="+mn-lt"/>
                   <a:ea typeface="+mn-ea"/>
                   <a:cs typeface="+mn-cs"/>
                 </a:rPr>
-                <a:t>Đối tượng: mentor và giảng viên EXE (Cô Lan, 3 lớp, nhiều ngành SE, AI, MKT, GD)</a:t>
+                <a:t>Người dùng: mentor và giảng viên EXE</a:t>
               </a:r>
             </a:p>
           </p:txBody>
@@ -2692,8 +2679,8 @@
           </p:nvSpPr>
           <p:spPr>
             <a:xfrm>
-              <a:off x="939800" y="6197600"/>
-              <a:ext cx="8128000" cy="558800"/>
+              <a:off x="939800" y="6050000"/>
+              <a:ext cx="9500000" cy="558800"/>
             </a:xfrm>
             <a:prstGeom prst="rect">
               <a:avLst/>
@@ -2709,11 +2696,16 @@
             </a:bodyPr>
             <a:lstStyle/>
             <a:p>
-              <a:pPr algn="l"/>
+              <a:pPr marL="0" indent="0" algn="l">
+                <a:lnSpc>
+                  <a:spcPts val="1750"/>
+                </a:lnSpc>
+                <a:buNone/>
+              </a:pPr>
               <a:r>
-                <a:rPr lang="vi" sz="1350" dirty="0">
+                <a:rPr lang="vi" sz="1400" dirty="0">
                   <a:solidFill>
-                    <a:schemeClr val="accent6"/>
+                    <a:srgbClr val="1C1B18"/>
                   </a:solidFill>
                   <a:latin typeface="+mn-lt"/>
                   <a:ea typeface="+mn-ea"/>
@@ -2721,36 +2713,28 @@
                 </a:rPr>
                 <a:t>GitHub: github.com/Kenn0679/prm323-lab2-group6</a:t>
               </a:r>
-              <a:endParaRPr lang="vi" sz="1350" b="1" dirty="0">
-                <a:solidFill>
-                  <a:schemeClr val="accent3"/>
-                </a:solidFill>
-                <a:latin typeface="+mn-lt"/>
-                <a:ea typeface="+mn-ea"/>
-                <a:cs typeface="+mn-cs"/>
-              </a:endParaRPr>
             </a:p>
             <a:p>
-              <a:pPr algn="l"/>
+              <a:pPr marL="0" indent="0" algn="l">
+                <a:lnSpc>
+                  <a:spcPts val="1750"/>
+                </a:lnSpc>
+                <a:spcBef>
+                  <a:spcPts val="200"/>
+                </a:spcBef>
+                <a:buNone/>
+              </a:pPr>
               <a:r>
-                <a:rPr lang="vi" sz="1350" dirty="0">
+                <a:rPr lang="vi" sz="1400" dirty="0">
                   <a:solidFill>
-                    <a:schemeClr val="accent6"/>
+                    <a:srgbClr val="1C1B18"/>
                   </a:solidFill>
                   <a:latin typeface="+mn-lt"/>
                   <a:ea typeface="+mn-ea"/>
                   <a:cs typeface="+mn-cs"/>
                 </a:rPr>
-                <a:t>Figma: figma.com/design/X5WcaK4s20AYF53cvRdouV/TeamUp-EXE---Mentor--PRM323-Lab-2-</a:t>
+                <a:t>Figma: figma.com/design/X5WcaK4s20AYF53cvRdouV</a:t>
               </a:r>
-              <a:endParaRPr lang="vi" sz="1350" b="1" dirty="0">
-                <a:solidFill>
-                  <a:schemeClr val="accent3"/>
-                </a:solidFill>
-                <a:latin typeface="+mn-lt"/>
-                <a:ea typeface="+mn-ea"/>
-                <a:cs typeface="+mn-cs"/>
-              </a:endParaRPr>
             </a:p>
           </p:txBody>
         </p:sp>
@@ -2849,7 +2833,7 @@
         <p:spPr>
           <a:xfrm>
             <a:off x="752856" y="1327150"/>
-            <a:ext cx="7295952" cy="2828544"/>
+            <a:ext cx="9900000" cy="4200000"/>
           </a:xfrm>
           <a:prstGeom prst="rect">
             <a:avLst/>
@@ -2860,159 +2844,159 @@
           </a:ln>
         </p:spPr>
         <p:txBody>
-          <a:bodyPr wrap="none" lIns="0" tIns="0" rIns="0" bIns="0" anchor="t" anchorCtr="0">
+          <a:bodyPr wrap="square" lIns="0" tIns="0" rIns="0" bIns="0" anchor="t" anchorCtr="0">
             <a:noAutofit/>
           </a:bodyPr>
           <a:lstStyle/>
           <a:p>
             <a:pPr marL="0" indent="0" algn="l">
               <a:lnSpc>
-                <a:spcPts val="2550"/>
+                <a:spcPts val="3240"/>
               </a:lnSpc>
               <a:buNone/>
             </a:pPr>
             <a:r>
-              <a:rPr lang="vi" sz="1800" b="1" dirty="0">
-                <a:solidFill>
-                  <a:schemeClr val="dk1"/>
-                </a:solidFill>
-                <a:latin typeface="+mn-lt"/>
-                <a:ea typeface="+mn-ea"/>
-                <a:cs typeface="+mn-cs"/>
-              </a:rPr>
-              <a:t>Chữ thường ≥4.5:1:</a:t>
-            </a:r>
-            <a:r>
-              <a:rPr lang="vi" sz="1800" dirty="0">
-                <a:solidFill>
-                  <a:schemeClr val="dk1"/>
-                </a:solidFill>
-                <a:latin typeface="+mn-lt"/>
-                <a:ea typeface="+mn-ea"/>
-                <a:cs typeface="+mn-cs"/>
-              </a:rPr>
-              <a:t> on-surface/surface 17.22; on-primary/primary 5.86; </a:t>
-            </a:r>
-            <a:r>
-              <a:rPr lang="vi" sz="1800" dirty="0">
-                <a:solidFill>
-                  <a:schemeClr val="dk1"/>
-                </a:solidFill>
-                <a:latin typeface="+mn-lt"/>
-                <a:ea typeface="+mn-ea"/>
-                <a:cs typeface="+mn-cs"/>
-              </a:rPr>
-              <a:t>error/error-container 5.14</a:t>
+              <a:rPr lang="vi" sz="2400" dirty="0" b="1">
+                <a:solidFill>
+                  <a:srgbClr val="1A56C8"/>
+                </a:solidFill>
+                <a:latin typeface="+mn-lt"/>
+                <a:ea typeface="+mn-ea"/>
+                <a:cs typeface="+mn-cs"/>
+              </a:rPr>
+              <a:t>Chữ thường ≥ 4.5:1: </a:t>
+            </a:r>
+            <a:r>
+              <a:rPr lang="vi" sz="2400" dirty="0">
+                <a:solidFill>
+                  <a:srgbClr val="1C1B18"/>
+                </a:solidFill>
+                <a:latin typeface="+mn-lt"/>
+                <a:ea typeface="+mn-ea"/>
+                <a:cs typeface="+mn-cs"/>
+              </a:rPr>
+              <a:t>17.22 / 5.86 / 5.14 (on-surface, on-primary, error)</a:t>
             </a:r>
           </a:p>
           <a:p>
             <a:pPr marL="0" indent="0" algn="l">
               <a:lnSpc>
-                <a:spcPts val="2550"/>
+                <a:spcPts val="3240"/>
               </a:lnSpc>
               <a:spcBef>
-                <a:spcPts val="1050"/>
+                <a:spcPts val="1800"/>
               </a:spcBef>
               <a:buNone/>
             </a:pPr>
             <a:r>
-              <a:rPr lang="vi" sz="1800" b="1" dirty="0">
-                <a:solidFill>
-                  <a:schemeClr val="dk1"/>
-                </a:solidFill>
-                <a:latin typeface="+mn-lt"/>
-                <a:ea typeface="+mn-ea"/>
-                <a:cs typeface="+mn-cs"/>
-              </a:rPr>
-              <a:t>Control ≥3:1:</a:t>
-            </a:r>
-            <a:r>
-              <a:rPr lang="vi" sz="1800" dirty="0">
-                <a:solidFill>
-                  <a:schemeClr val="dk1"/>
-                </a:solidFill>
-                <a:latin typeface="+mn-lt"/>
-                <a:ea typeface="+mn-ea"/>
-                <a:cs typeface="+mn-cs"/>
-              </a:rPr>
-              <a:t> outline/surface 4.61; viền ô đề xuất 4.76; </a:t>
-            </a:r>
-            <a:r>
-              <a:rPr lang="vi" sz="1800" dirty="0">
-                <a:solidFill>
-                  <a:schemeClr val="dk1"/>
-                </a:solidFill>
-                <a:latin typeface="+mn-lt"/>
-                <a:ea typeface="+mn-ea"/>
-                <a:cs typeface="+mn-cs"/>
-              </a:rPr>
-              <a:t>viền thẻ 1.48 (ngoại lệ, chỉ phân tách)</a:t>
+              <a:rPr lang="vi" sz="2400" dirty="0" b="1">
+                <a:solidFill>
+                  <a:srgbClr val="1A56C8"/>
+                </a:solidFill>
+                <a:latin typeface="+mn-lt"/>
+                <a:ea typeface="+mn-ea"/>
+                <a:cs typeface="+mn-cs"/>
+              </a:rPr>
+              <a:t>Control ≥ 3:1: </a:t>
+            </a:r>
+            <a:r>
+              <a:rPr lang="vi" sz="2400" dirty="0">
+                <a:solidFill>
+                  <a:srgbClr val="1C1B18"/>
+                </a:solidFill>
+                <a:latin typeface="+mn-lt"/>
+                <a:ea typeface="+mn-ea"/>
+                <a:cs typeface="+mn-cs"/>
+              </a:rPr>
+              <a:t>outline 4.61; viền ô đề xuất 4.76</a:t>
             </a:r>
           </a:p>
           <a:p>
             <a:pPr marL="0" indent="0" algn="l">
               <a:lnSpc>
-                <a:spcPts val="2550"/>
+                <a:spcPts val="3240"/>
               </a:lnSpc>
               <a:spcBef>
-                <a:spcPts val="1050"/>
+                <a:spcPts val="1800"/>
               </a:spcBef>
               <a:buNone/>
             </a:pPr>
             <a:r>
-              <a:rPr lang="vi" sz="1800" dirty="0">
-                <a:solidFill>
-                  <a:schemeClr val="dk1"/>
-                </a:solidFill>
-                <a:latin typeface="+mn-lt"/>
-                <a:ea typeface="+mn-ea"/>
-                <a:cs typeface="+mn-cs"/>
-              </a:rPr>
-              <a:t>Touch target ≥48 dp; chữ ≥14 sp; không chỉ dùng màu để báo trạng thái</a:t>
+              <a:rPr lang="vi" sz="2400" dirty="0" b="1">
+                <a:solidFill>
+                  <a:srgbClr val="1A56C8"/>
+                </a:solidFill>
+                <a:latin typeface="+mn-lt"/>
+                <a:ea typeface="+mn-ea"/>
+                <a:cs typeface="+mn-cs"/>
+              </a:rPr>
+              <a:t>Touch target ≥ 48 dp; </a:t>
+            </a:r>
+            <a:r>
+              <a:rPr lang="vi" sz="2400" dirty="0">
+                <a:solidFill>
+                  <a:srgbClr val="1C1B18"/>
+                </a:solidFill>
+                <a:latin typeface="+mn-lt"/>
+                <a:ea typeface="+mn-ea"/>
+                <a:cs typeface="+mn-cs"/>
+              </a:rPr>
+              <a:t>chữ ≥ 14 sp (đã quét 25 màn: 0 chữ nhỏ hơn)</a:t>
             </a:r>
           </a:p>
           <a:p>
             <a:pPr marL="0" indent="0" algn="l">
               <a:lnSpc>
-                <a:spcPts val="2550"/>
+                <a:spcPts val="3240"/>
               </a:lnSpc>
               <a:spcBef>
-                <a:spcPts val="1050"/>
+                <a:spcPts val="1800"/>
               </a:spcBef>
               <a:buNone/>
             </a:pPr>
             <a:r>
-              <a:rPr lang="vi" sz="1800" dirty="0">
-                <a:solidFill>
-                  <a:schemeClr val="dk1"/>
-                </a:solidFill>
-                <a:latin typeface="+mn-lt"/>
-                <a:ea typeface="+mn-ea"/>
-                <a:cs typeface="+mn-cs"/>
-              </a:rPr>
-              <a:t>Kiểm ở 360 dp và 412 dp: 360 dp đạt (21 frame 360×800, 0 chữ &lt;14 sp); 412 dp chưa kiểm</a:t>
+              <a:rPr lang="vi" sz="2400" dirty="0">
+                <a:solidFill>
+                  <a:srgbClr val="1C1B18"/>
+                </a:solidFill>
+                <a:latin typeface="+mn-lt"/>
+                <a:ea typeface="+mn-ea"/>
+                <a:cs typeface="+mn-cs"/>
+              </a:rPr>
+              <a:t>Trạng thái luôn kèm chữ, không chỉ dùng màu</a:t>
             </a:r>
           </a:p>
           <a:p>
             <a:pPr marL="0" indent="0" algn="l">
               <a:lnSpc>
-                <a:spcPts val="2550"/>
+                <a:spcPts val="3240"/>
               </a:lnSpc>
               <a:spcBef>
-                <a:spcPts val="1050"/>
+                <a:spcPts val="1800"/>
               </a:spcBef>
               <a:buNone/>
             </a:pPr>
             <a:r>
-              <a:rPr lang="vi" sz="1800" dirty="0">
-                <a:solidFill>
-                  <a:schemeClr val="dk1"/>
-                </a:solidFill>
-                <a:latin typeface="+mn-lt"/>
-                <a:ea typeface="+mn-ea"/>
-                <a:cs typeface="+mn-cs"/>
-              </a:rPr>
-              <a:t>Màn rộng ≥600 dp: NavigationRail và master-detail (chỉ đặc tả)</a:t>
+              <a:rPr lang="vi" sz="2400" dirty="0" b="1">
+                <a:solidFill>
+                  <a:srgbClr val="1A56C8"/>
+                </a:solidFill>
+                <a:latin typeface="+mn-lt"/>
+                <a:ea typeface="+mn-ea"/>
+                <a:cs typeface="+mn-cs"/>
+              </a:rPr>
+              <a:t>Chưa kiểm: </a:t>
+            </a:r>
+            <a:r>
+              <a:rPr lang="vi" sz="2400" dirty="0">
+                <a:solidFill>
+                  <a:srgbClr val="1C1B18"/>
+                </a:solidFill>
+                <a:latin typeface="+mn-lt"/>
+                <a:ea typeface="+mn-ea"/>
+                <a:cs typeface="+mn-cs"/>
+              </a:rPr>
+              <a:t>412 dp; màn ≥ 600 dp mới chỉ đặc tả</a:t>
             </a:r>
           </a:p>
         </p:txBody>
@@ -3046,7 +3030,7 @@
               <a:avLst/>
             </a:prstGeom>
             <a:solidFill>
-              <a:schemeClr val="accent2"/>
+              <a:srgbClr val="1A56C8"/>
             </a:solidFill>
             <a:ln>
               <a:noFill/>
@@ -3102,9 +3086,9 @@
             <a:p>
               <a:pPr algn="l"/>
               <a:r>
-                <a:rPr lang="vi" sz="1350" dirty="0">
+                <a:rPr lang="vi" sz="1200" dirty="0">
                   <a:solidFill>
-                    <a:schemeClr val="accent6"/>
+                    <a:srgbClr val="555555"/>
                   </a:solidFill>
                   <a:latin typeface="+mn-lt"/>
                   <a:ea typeface="+mn-ea"/>
@@ -3210,7 +3194,7 @@
         <p:spPr>
           <a:xfrm>
             <a:off x="752856" y="1517650"/>
-            <a:ext cx="7401336" cy="2618994"/>
+            <a:ext cx="9900000" cy="3200000"/>
           </a:xfrm>
           <a:prstGeom prst="rect">
             <a:avLst/>
@@ -3221,104 +3205,93 @@
           </a:ln>
         </p:spPr>
         <p:txBody>
-          <a:bodyPr wrap="none" lIns="0" tIns="0" rIns="0" bIns="0" anchor="t" anchorCtr="0">
+          <a:bodyPr wrap="square" lIns="0" tIns="0" rIns="0" bIns="0" anchor="t" anchorCtr="0">
             <a:noAutofit/>
           </a:bodyPr>
           <a:lstStyle/>
           <a:p>
             <a:pPr marL="0" indent="0" algn="l">
               <a:lnSpc>
-                <a:spcPts val="2550"/>
+                <a:spcPts val="3240"/>
               </a:lnSpc>
               <a:buNone/>
             </a:pPr>
             <a:r>
-              <a:rPr lang="vi" sz="1800" dirty="0">
-                <a:solidFill>
-                  <a:schemeClr val="dk1"/>
-                </a:solidFill>
-                <a:latin typeface="+mn-lt"/>
-                <a:ea typeface="+mn-ea"/>
-                <a:cs typeface="+mn-cs"/>
-              </a:rPr>
-              <a:t>3 flow bấm được từ điểm bắt đầu đến kết thúc, không ngõ cụt </a:t>
-            </a:r>
-            <a:r>
-              <a:rPr lang="vi" sz="1800" dirty="0">
-                <a:solidFill>
-                  <a:schemeClr val="dk1"/>
-                </a:solidFill>
-                <a:latin typeface="+mn-lt"/>
-                <a:ea typeface="+mn-ea"/>
-                <a:cs typeface="+mn-cs"/>
-              </a:rPr>
-              <a:t>(đã kiểm bằng script: mọi màn tới được từ điểm bắt đầu). Cuối mỗi flow có banner "hoàn tất" kèm nút làm lại</a:t>
+              <a:rPr lang="vi" sz="2400" dirty="0">
+                <a:solidFill>
+                  <a:srgbClr val="1C1B18"/>
+                </a:solidFill>
+                <a:latin typeface="+mn-lt"/>
+                <a:ea typeface="+mn-ea"/>
+                <a:cs typeface="+mn-cs"/>
+              </a:rPr>
+              <a:t>35 frame, 3 flow bấm được từ điểm bắt đầu đến kết thúc, không ngõ cụt</a:t>
             </a:r>
           </a:p>
           <a:p>
             <a:pPr marL="0" indent="0" algn="l">
               <a:lnSpc>
-                <a:spcPts val="2550"/>
+                <a:spcPts val="3240"/>
               </a:lnSpc>
               <a:spcBef>
-                <a:spcPts val="2550"/>
+                <a:spcPts val="1800"/>
               </a:spcBef>
               <a:buNone/>
             </a:pPr>
             <a:r>
-              <a:rPr lang="vi" sz="1800" dirty="0">
-                <a:solidFill>
-                  <a:schemeClr val="dk1"/>
-                </a:solidFill>
-                <a:latin typeface="+mn-lt"/>
-                <a:ea typeface="+mn-ea"/>
-                <a:cs typeface="+mn-cs"/>
-              </a:rPr>
-              <a:t>Dialog dạng overlay: S12 Approve và S17 Discard</a:t>
+              <a:rPr lang="vi" sz="2400" dirty="0">
+                <a:solidFill>
+                  <a:srgbClr val="1C1B18"/>
+                </a:solidFill>
+                <a:latin typeface="+mn-lt"/>
+                <a:ea typeface="+mn-ea"/>
+                <a:cs typeface="+mn-cs"/>
+              </a:rPr>
+              <a:t>Dialog dạng overlay: S12, S17, S24</a:t>
             </a:r>
           </a:p>
           <a:p>
             <a:pPr marL="0" indent="0" algn="l">
               <a:lnSpc>
-                <a:spcPts val="2550"/>
+                <a:spcPts val="3240"/>
               </a:lnSpc>
               <a:spcBef>
-                <a:spcPts val="2550"/>
+                <a:spcPts val="1800"/>
               </a:spcBef>
               <a:buNone/>
             </a:pPr>
             <a:r>
-              <a:rPr lang="vi" sz="1800" dirty="0">
-                <a:solidFill>
-                  <a:schemeClr val="dk1"/>
-                </a:solidFill>
-                <a:latin typeface="+mn-lt"/>
-                <a:ea typeface="+mn-ea"/>
-                <a:cs typeface="+mn-cs"/>
-              </a:rPr>
-              <a:t>Loading → kết quả: S8 AI matching → S9 Proposals hoặc S15 No match</a:t>
+              <a:rPr lang="vi" sz="2400" dirty="0">
+                <a:solidFill>
+                  <a:srgbClr val="1C1B18"/>
+                </a:solidFill>
+                <a:latin typeface="+mn-lt"/>
+                <a:ea typeface="+mn-ea"/>
+                <a:cs typeface="+mn-cs"/>
+              </a:rPr>
+              <a:t>Loading S8 → S9 Proposals hoặc S15 No match</a:t>
             </a:r>
           </a:p>
           <a:p>
             <a:pPr marL="0" indent="0" algn="l">
               <a:lnSpc>
-                <a:spcPts val="2550"/>
+                <a:spcPts val="3240"/>
               </a:lnSpc>
               <a:spcBef>
-                <a:spcPts val="2550"/>
+                <a:spcPts val="1800"/>
               </a:spcBef>
               <a:buNone/>
             </a:pPr>
             <a:r>
-              <a:rPr lang="vi" sz="1800" dirty="0">
-                <a:solidFill>
-                  <a:schemeClr val="dk1"/>
-                </a:solidFill>
-                <a:latin typeface="+mn-lt"/>
-                <a:ea typeface="+mn-ea"/>
-                <a:cs typeface="+mn-cs"/>
-              </a:rPr>
-              <a:t>Back quay đúng màn trước; chip lọc, checkbox, công tắc Notifications và Language bấm đổi trạng thái</a:t>
+              <a:rPr lang="vi" sz="2400" dirty="0">
+                <a:solidFill>
+                  <a:srgbClr val="1C1B18"/>
+                </a:solidFill>
+                <a:latin typeface="+mn-lt"/>
+                <a:ea typeface="+mn-ea"/>
+                <a:cs typeface="+mn-cs"/>
+              </a:rPr>
+              <a:t>Back quay đúng màn trước</a:t>
             </a:r>
           </a:p>
         </p:txBody>
@@ -3352,7 +3325,7 @@
               <a:avLst/>
             </a:prstGeom>
             <a:solidFill>
-              <a:schemeClr val="accent5"/>
+              <a:srgbClr val="1A56C8"/>
             </a:solidFill>
             <a:ln>
               <a:noFill/>
@@ -3410,7 +3383,7 @@
               <a:r>
                 <a:rPr lang="vi" sz="2400" b="1" dirty="0">
                   <a:solidFill>
-                    <a:schemeClr val="accent5"/>
+                    <a:srgbClr val="1A56C8"/>
                   </a:solidFill>
                   <a:latin typeface="+mn-lt"/>
                   <a:ea typeface="+mn-ea"/>
@@ -3463,9 +3436,9 @@
             <a:p>
               <a:pPr algn="l"/>
               <a:r>
-                <a:rPr lang="vi" sz="1350" dirty="0">
+                <a:rPr lang="vi" sz="1200" dirty="0">
                   <a:solidFill>
-                    <a:schemeClr val="accent6"/>
+                    <a:srgbClr val="555555"/>
                   </a:solidFill>
                   <a:latin typeface="+mn-lt"/>
                   <a:ea typeface="+mn-ea"/>
@@ -3571,7 +3544,7 @@
         <p:spPr>
           <a:xfrm>
             <a:off x="752856" y="1327150"/>
-            <a:ext cx="7285802" cy="3019044"/>
+            <a:ext cx="9900000" cy="3600000"/>
           </a:xfrm>
           <a:prstGeom prst="rect">
             <a:avLst/>
@@ -3582,148 +3555,115 @@
           </a:ln>
         </p:spPr>
         <p:txBody>
-          <a:bodyPr wrap="none" lIns="0" tIns="0" rIns="0" bIns="0" anchor="t" anchorCtr="0">
+          <a:bodyPr wrap="square" lIns="0" tIns="0" rIns="0" bIns="0" anchor="t" anchorCtr="0">
             <a:noAutofit/>
           </a:bodyPr>
           <a:lstStyle/>
           <a:p>
             <a:pPr marL="0" indent="0" algn="l">
               <a:lnSpc>
-                <a:spcPts val="2550"/>
+                <a:spcPts val="3240"/>
               </a:lnSpc>
               <a:buNone/>
             </a:pPr>
             <a:r>
-              <a:rPr lang="vi" sz="1800" dirty="0">
-                <a:solidFill>
-                  <a:schemeClr val="dk1"/>
-                </a:solidFill>
-                <a:latin typeface="+mn-lt"/>
-                <a:ea typeface="+mn-ea"/>
-                <a:cs typeface="+mn-cs"/>
-              </a:rPr>
-              <a:t>Mỗi màn có 6 mục: layout, components, states, interactions, </a:t>
-            </a:r>
-            <a:r>
-              <a:rPr lang="vi" sz="1800" dirty="0">
-                <a:solidFill>
-                  <a:schemeClr val="dk1"/>
-                </a:solidFill>
-                <a:latin typeface="+mn-lt"/>
-                <a:ea typeface="+mn-ea"/>
-                <a:cs typeface="+mn-cs"/>
-              </a:rPr>
-              <a:t>navigation, constraints (25 màn)</a:t>
+              <a:rPr lang="vi" sz="2400" dirty="0">
+                <a:solidFill>
+                  <a:srgbClr val="1C1B18"/>
+                </a:solidFill>
+                <a:latin typeface="+mn-lt"/>
+                <a:ea typeface="+mn-ea"/>
+                <a:cs typeface="+mn-cs"/>
+              </a:rPr>
+              <a:t>Mỗi màn có 6 mục: layout, components, states, interactions, navigation, constraints</a:t>
             </a:r>
           </a:p>
           <a:p>
             <a:pPr marL="0" indent="0" algn="l">
               <a:lnSpc>
-                <a:spcPts val="2550"/>
+                <a:spcPts val="3240"/>
               </a:lnSpc>
               <a:spcBef>
-                <a:spcPts val="1050"/>
+                <a:spcPts val="1800"/>
               </a:spcBef>
               <a:buNone/>
             </a:pPr>
             <a:r>
-              <a:rPr lang="vi" sz="1800" dirty="0">
-                <a:solidFill>
-                  <a:schemeClr val="dk1"/>
-                </a:solidFill>
-                <a:latin typeface="+mn-lt"/>
-                <a:ea typeface="+mn-ea"/>
-                <a:cs typeface="+mn-cs"/>
-              </a:rPr>
-              <a:t>Hai bảng: token → Flutter (ColorScheme, TextTheme, hằng số) </a:t>
-            </a:r>
-            <a:r>
-              <a:rPr lang="vi" sz="1800" dirty="0">
-                <a:solidFill>
-                  <a:schemeClr val="dk1"/>
-                </a:solidFill>
-                <a:latin typeface="+mn-lt"/>
-                <a:ea typeface="+mn-ea"/>
-                <a:cs typeface="+mn-cs"/>
-              </a:rPr>
-              <a:t>và component → widget (FilledButton, TextFormField, NavigationBar…)</a:t>
+              <a:rPr lang="vi" sz="2400" dirty="0">
+                <a:solidFill>
+                  <a:srgbClr val="1C1B18"/>
+                </a:solidFill>
+                <a:latin typeface="+mn-lt"/>
+                <a:ea typeface="+mn-ea"/>
+                <a:cs typeface="+mn-cs"/>
+              </a:rPr>
+              <a:t>2 bảng: token → Flutter, component → widget</a:t>
             </a:r>
           </a:p>
           <a:p>
             <a:pPr marL="0" indent="0" algn="l">
               <a:lnSpc>
-                <a:spcPts val="2550"/>
+                <a:spcPts val="3240"/>
               </a:lnSpc>
               <a:spcBef>
-                <a:spcPts val="1050"/>
+                <a:spcPts val="1800"/>
               </a:spcBef>
               <a:buNone/>
             </a:pPr>
             <a:r>
-              <a:rPr lang="vi" sz="1800" dirty="0">
-                <a:solidFill>
-                  <a:schemeClr val="dk1"/>
-                </a:solidFill>
-                <a:latin typeface="+mn-lt"/>
-                <a:ea typeface="+mn-ea"/>
-                <a:cs typeface="+mn-cs"/>
-              </a:rPr>
-              <a:t>Màn rộng ≥600 dp mô tả trong handoff</a:t>
+              <a:rPr lang="vi" sz="2400" dirty="0" b="1">
+                <a:solidFill>
+                  <a:srgbClr val="1A56C8"/>
+                </a:solidFill>
+                <a:latin typeface="+mn-lt"/>
+                <a:ea typeface="+mn-ea"/>
+                <a:cs typeface="+mn-cs"/>
+              </a:rPr>
+              <a:t>Hạn chế: </a:t>
+            </a:r>
+            <a:r>
+              <a:rPr lang="vi" sz="2400" dirty="0">
+                <a:solidFill>
+                  <a:srgbClr val="1C1B18"/>
+                </a:solidFill>
+                <a:latin typeface="+mn-lt"/>
+                <a:ea typeface="+mn-ea"/>
+                <a:cs typeface="+mn-cs"/>
+              </a:rPr>
+              <a:t>AI chỉ là thiết kế giao diện với dữ liệu mẫu, chưa có mô hình thật</a:t>
             </a:r>
           </a:p>
           <a:p>
             <a:pPr marL="0" indent="0" algn="l">
               <a:lnSpc>
-                <a:spcPts val="2550"/>
+                <a:spcPts val="3240"/>
               </a:lnSpc>
               <a:spcBef>
-                <a:spcPts val="1050"/>
+                <a:spcPts val="1800"/>
               </a:spcBef>
               <a:buNone/>
             </a:pPr>
             <a:r>
-              <a:rPr lang="vi" sz="1800" b="1" dirty="0">
-                <a:solidFill>
-                  <a:schemeClr val="accent3"/>
-                </a:solidFill>
-                <a:latin typeface="+mn-lt"/>
-                <a:ea typeface="+mn-ea"/>
-                <a:cs typeface="+mn-cs"/>
-              </a:rPr>
-              <a:t>Hạn chế:</a:t>
-            </a:r>
-            <a:r>
-              <a:rPr lang="vi" sz="1800" dirty="0">
-                <a:solidFill>
-                  <a:schemeClr val="dk1"/>
-                </a:solidFill>
-                <a:latin typeface="+mn-lt"/>
-                <a:ea typeface="+mn-ea"/>
-                <a:cs typeface="+mn-cs"/>
-              </a:rPr>
-              <a:t> AI ghép nhóm chỉ là thiết kế giao diện với dữ liệu mẫu, </a:t>
-            </a:r>
-            <a:r>
-              <a:rPr lang="vi" sz="1800" dirty="0">
-                <a:solidFill>
-                  <a:schemeClr val="dk1"/>
-                </a:solidFill>
-                <a:latin typeface="+mn-lt"/>
-                <a:ea typeface="+mn-ea"/>
-                <a:cs typeface="+mn-cs"/>
-              </a:rPr>
-              <a:t>không có mô hình thật; lỗi kích thước từ Stitch đã sửa trong Figma </a:t>
-            </a:r>
-            <a:r>
-              <a:rPr lang="vi" sz="1800" dirty="0">
-                <a:solidFill>
-                  <a:schemeClr val="dk1"/>
-                </a:solidFill>
-                <a:latin typeface="+mn-lt"/>
-                <a:ea typeface="+mn-ea"/>
-                <a:cs typeface="+mn-cs"/>
-              </a:rPr>
-              <a:t>(21 frame 360×800)</a:t>
+              <a:rPr lang="vi" sz="2400" dirty="0" b="1">
+                <a:solidFill>
+                  <a:srgbClr val="1A56C8"/>
+                </a:solidFill>
+                <a:latin typeface="+mn-lt"/>
+                <a:ea typeface="+mn-ea"/>
+                <a:cs typeface="+mn-cs"/>
+              </a:rPr>
+              <a:t>Chưa làm: </a:t>
+            </a:r>
+            <a:r>
+              <a:rPr lang="vi" sz="2400" dirty="0">
+                <a:solidFill>
+                  <a:srgbClr val="1C1B18"/>
+                </a:solidFill>
+                <a:latin typeface="+mn-lt"/>
+                <a:ea typeface="+mn-ea"/>
+                <a:cs typeface="+mn-cs"/>
+              </a:rPr>
+              <a:t>kiểm 412 dp, kiểm với người dùng thật</a:t>
             </a:r>
           </a:p>
         </p:txBody>
@@ -3757,7 +3697,7 @@
               <a:avLst/>
             </a:prstGeom>
             <a:solidFill>
-              <a:schemeClr val="accent5"/>
+              <a:srgbClr val="1A56C8"/>
             </a:solidFill>
             <a:ln>
               <a:noFill/>
@@ -3815,7 +3755,7 @@
               <a:r>
                 <a:rPr lang="vi" sz="2400" b="1" dirty="0">
                   <a:solidFill>
-                    <a:schemeClr val="accent1"/>
+                    <a:srgbClr val="1A56C8"/>
                   </a:solidFill>
                   <a:latin typeface="+mn-lt"/>
                   <a:ea typeface="+mn-ea"/>
@@ -3868,9 +3808,9 @@
             <a:p>
               <a:pPr algn="l"/>
               <a:r>
-                <a:rPr lang="vi" sz="1350" dirty="0">
+                <a:rPr lang="vi" sz="1200" dirty="0">
                   <a:solidFill>
-                    <a:schemeClr val="accent6"/>
+                    <a:srgbClr val="555555"/>
                   </a:solidFill>
                   <a:latin typeface="+mn-lt"/>
                   <a:ea typeface="+mn-ea"/>
@@ -3976,7 +3916,7 @@
         <p:spPr>
           <a:xfrm>
             <a:off x="752856" y="1327150"/>
-            <a:ext cx="7960492" cy="3400044"/>
+            <a:ext cx="9900000" cy="4200000"/>
           </a:xfrm>
           <a:prstGeom prst="rect">
             <a:avLst/>
@@ -3987,214 +3927,170 @@
           </a:ln>
         </p:spPr>
         <p:txBody>
-          <a:bodyPr wrap="none" lIns="0" tIns="0" rIns="0" bIns="0" anchor="t" anchorCtr="0">
+          <a:bodyPr wrap="square" lIns="0" tIns="0" rIns="0" bIns="0" anchor="t" anchorCtr="0">
             <a:noAutofit/>
           </a:bodyPr>
           <a:lstStyle/>
           <a:p>
             <a:pPr marL="0" indent="0" algn="l">
               <a:lnSpc>
-                <a:spcPts val="2550"/>
+                <a:spcPts val="3240"/>
               </a:lnSpc>
               <a:buNone/>
             </a:pPr>
             <a:r>
-              <a:rPr lang="vi" sz="1800" b="1" dirty="0">
-                <a:solidFill>
-                  <a:schemeClr val="accent1"/>
-                </a:solidFill>
-                <a:latin typeface="+mn-lt"/>
-                <a:ea typeface="+mn-ea"/>
-                <a:cs typeface="+mn-cs"/>
-              </a:rPr>
-              <a:t>Persona:</a:t>
-            </a:r>
-            <a:r>
-              <a:rPr lang="vi" sz="1800" dirty="0">
-                <a:solidFill>
-                  <a:schemeClr val="dk1"/>
-                </a:solidFill>
-                <a:latin typeface="+mn-lt"/>
-                <a:ea typeface="+mn-ea"/>
-                <a:cs typeface="+mn-cs"/>
-              </a:rPr>
-              <a:t> Cô Lan, 38 tuổi, giảng viên và mentor 3 lớp EXE (~40 sinh viên/lớp)</a:t>
+              <a:rPr lang="vi" sz="2400" dirty="0" b="1">
+                <a:solidFill>
+                  <a:srgbClr val="1A56C8"/>
+                </a:solidFill>
+                <a:latin typeface="+mn-lt"/>
+                <a:ea typeface="+mn-ea"/>
+                <a:cs typeface="+mn-cs"/>
+              </a:rPr>
+              <a:t>Persona: </a:t>
+            </a:r>
+            <a:r>
+              <a:rPr lang="vi" sz="2400" dirty="0">
+                <a:solidFill>
+                  <a:srgbClr val="1C1B18"/>
+                </a:solidFill>
+                <a:latin typeface="+mn-lt"/>
+                <a:ea typeface="+mn-ea"/>
+                <a:cs typeface="+mn-cs"/>
+              </a:rPr>
+              <a:t>Cô Lan, 38 tuổi, mentor 3 lớp EXE (~40 sinh viên mỗi lớp)</a:t>
             </a:r>
           </a:p>
           <a:p>
             <a:pPr marL="0" indent="0" algn="l">
               <a:lnSpc>
-                <a:spcPts val="2550"/>
+                <a:spcPts val="3240"/>
               </a:lnSpc>
               <a:spcBef>
-                <a:spcPts val="900"/>
+                <a:spcPts val="1800"/>
               </a:spcBef>
               <a:buNone/>
             </a:pPr>
             <a:r>
-              <a:rPr lang="vi" sz="1800" b="1" dirty="0">
-                <a:solidFill>
-                  <a:schemeClr val="accent1"/>
-                </a:solidFill>
-                <a:latin typeface="+mn-lt"/>
-                <a:ea typeface="+mn-ea"/>
-                <a:cs typeface="+mn-cs"/>
-              </a:rPr>
-              <a:t>Pain points:</a:t>
-            </a:r>
-            <a:r>
-              <a:rPr lang="vi" sz="1800" dirty="0">
-                <a:solidFill>
-                  <a:schemeClr val="dk1"/>
-                </a:solidFill>
-                <a:latin typeface="+mn-lt"/>
-                <a:ea typeface="+mn-ea"/>
-                <a:cs typeface="+mn-cs"/>
-              </a:rPr>
-              <a:t> nhiều bạn chưa có nhóm; ghép tay bằng Excel và tin nhắn </a:t>
-            </a:r>
-            <a:r>
-              <a:rPr lang="vi" sz="1800" dirty="0">
-                <a:solidFill>
-                  <a:schemeClr val="dk1"/>
-                </a:solidFill>
-                <a:latin typeface="+mn-lt"/>
-                <a:ea typeface="+mn-ea"/>
-                <a:cs typeface="+mn-cs"/>
-              </a:rPr>
-              <a:t>khó nhớ ngành, kỹ năng, lịch rảnh; ghép vội thì nhóm lệch ngành </a:t>
-            </a:r>
-            <a:r>
-              <a:rPr lang="vi" sz="1800" dirty="0">
-                <a:solidFill>
-                  <a:schemeClr val="dk1"/>
-                </a:solidFill>
-                <a:latin typeface="+mn-lt"/>
-                <a:ea typeface="+mn-ea"/>
-                <a:cs typeface="+mn-cs"/>
-              </a:rPr>
-              <a:t>(chỉ lộ ra giữa kỳ); mentor chỉ có vài phút mỗi lần</a:t>
+              <a:rPr lang="vi" sz="2400" dirty="0" b="1">
+                <a:solidFill>
+                  <a:srgbClr val="1A56C8"/>
+                </a:solidFill>
+                <a:latin typeface="+mn-lt"/>
+                <a:ea typeface="+mn-ea"/>
+                <a:cs typeface="+mn-cs"/>
+              </a:rPr>
+              <a:t>Vấn đề: </a:t>
+            </a:r>
+            <a:r>
+              <a:rPr lang="vi" sz="2400" dirty="0">
+                <a:solidFill>
+                  <a:srgbClr val="1C1B18"/>
+                </a:solidFill>
+                <a:latin typeface="+mn-lt"/>
+                <a:ea typeface="+mn-ea"/>
+                <a:cs typeface="+mn-cs"/>
+              </a:rPr>
+              <a:t>ghép nhóm bằng Excel và tin nhắn: tốn thời gian, dễ lệch ngành</a:t>
             </a:r>
           </a:p>
           <a:p>
             <a:pPr marL="0" indent="0" algn="l">
               <a:lnSpc>
-                <a:spcPts val="2550"/>
+                <a:spcPts val="3240"/>
               </a:lnSpc>
               <a:spcBef>
-                <a:spcPts val="900"/>
+                <a:spcPts val="1800"/>
               </a:spcBef>
               <a:buNone/>
             </a:pPr>
             <a:r>
-              <a:rPr lang="vi" sz="1800" b="1" dirty="0">
-                <a:solidFill>
-                  <a:schemeClr val="accent1"/>
-                </a:solidFill>
-                <a:latin typeface="+mn-lt"/>
-                <a:ea typeface="+mn-ea"/>
-                <a:cs typeface="+mn-cs"/>
-              </a:rPr>
-              <a:t>Vấn đề:</a:t>
-            </a:r>
-            <a:r>
-              <a:rPr lang="vi" sz="1800" dirty="0">
-                <a:solidFill>
-                  <a:schemeClr val="dk1"/>
-                </a:solidFill>
-                <a:latin typeface="+mn-lt"/>
-                <a:ea typeface="+mn-ea"/>
-                <a:cs typeface="+mn-cs"/>
-              </a:rPr>
-              <a:t> mentor có sinh viên chưa có nhóm và nhóm thiếu chuyên môn, nhưng </a:t>
-            </a:r>
-            <a:r>
-              <a:rPr lang="vi" sz="1800" dirty="0">
-                <a:solidFill>
-                  <a:schemeClr val="dk1"/>
-                </a:solidFill>
-                <a:latin typeface="+mn-lt"/>
-                <a:ea typeface="+mn-ea"/>
-                <a:cs typeface="+mn-cs"/>
-              </a:rPr>
-              <a:t>phải ghép thủ công nên mất thời gian và dễ lệch ngành</a:t>
+              <a:rPr lang="vi" sz="2400" dirty="0" b="1">
+                <a:solidFill>
+                  <a:srgbClr val="1A56C8"/>
+                </a:solidFill>
+                <a:latin typeface="+mn-lt"/>
+                <a:ea typeface="+mn-ea"/>
+                <a:cs typeface="+mn-cs"/>
+              </a:rPr>
+              <a:t>Luật nhóm: </a:t>
+            </a:r>
+            <a:r>
+              <a:rPr lang="vi" sz="2400" dirty="0">
+                <a:solidFill>
+                  <a:srgbClr val="1C1B18"/>
+                </a:solidFill>
+                <a:latin typeface="+mn-lt"/>
+                <a:ea typeface="+mn-ea"/>
+                <a:cs typeface="+mn-cs"/>
+              </a:rPr>
+              <a:t>5-6 người, ghép theo ngành (SE, AI, GD, MKT)</a:t>
             </a:r>
           </a:p>
           <a:p>
             <a:pPr marL="0" indent="0" algn="l">
               <a:lnSpc>
-                <a:spcPts val="2550"/>
+                <a:spcPts val="3240"/>
               </a:lnSpc>
               <a:spcBef>
-                <a:spcPts val="900"/>
+                <a:spcPts val="1800"/>
               </a:spcBef>
               <a:buNone/>
             </a:pPr>
             <a:r>
-              <a:rPr lang="vi" sz="1800" b="1" dirty="0">
-                <a:solidFill>
-                  <a:schemeClr val="accent1"/>
-                </a:solidFill>
-                <a:latin typeface="+mn-lt"/>
-                <a:ea typeface="+mn-ea"/>
-                <a:cs typeface="+mn-cs"/>
-              </a:rPr>
-              <a:t>Tiêu chí:</a:t>
-            </a:r>
-            <a:r>
-              <a:rPr lang="vi" sz="1800" dirty="0">
-                <a:solidFill>
-                  <a:schemeClr val="dk1"/>
-                </a:solidFill>
-                <a:latin typeface="+mn-lt"/>
-                <a:ea typeface="+mn-ea"/>
-                <a:cs typeface="+mn-cs"/>
-              </a:rPr>
-              <a:t> (1) duyệt gợi ý AI cho một lớp dưới 5 phút; (2) mỗi nhóm 4-6 người, </a:t>
-            </a:r>
-            <a:r>
-              <a:rPr lang="vi" sz="1800" dirty="0">
-                <a:solidFill>
-                  <a:schemeClr val="dk1"/>
-                </a:solidFill>
-                <a:latin typeface="+mn-lt"/>
-                <a:ea typeface="+mn-ea"/>
-                <a:cs typeface="+mn-cs"/>
-              </a:rPr>
-              <a:t>ít nhất 3 ngành; (3) thêm hoặc đổi một thành viên rồi duyệt dưới 60 giây</a:t>
+              <a:rPr lang="vi" sz="2400" dirty="0" b="1">
+                <a:solidFill>
+                  <a:srgbClr val="1A56C8"/>
+                </a:solidFill>
+                <a:latin typeface="+mn-lt"/>
+                <a:ea typeface="+mn-ea"/>
+                <a:cs typeface="+mn-cs"/>
+              </a:rPr>
+              <a:t>Mục tiêu: </a:t>
+            </a:r>
+            <a:r>
+              <a:rPr lang="vi" sz="2400" dirty="0">
+                <a:solidFill>
+                  <a:srgbClr val="1C1B18"/>
+                </a:solidFill>
+                <a:latin typeface="+mn-lt"/>
+                <a:ea typeface="+mn-ea"/>
+                <a:cs typeface="+mn-cs"/>
+              </a:rPr>
+              <a:t>duyệt gợi ý cho một lớp dưới 5 phút; đổi một thành viên và duyệt dưới 60 giây</a:t>
             </a:r>
           </a:p>
           <a:p>
             <a:pPr marL="0" indent="0" algn="l">
               <a:lnSpc>
-                <a:spcPts val="2550"/>
+                <a:spcPts val="3240"/>
               </a:lnSpc>
               <a:spcBef>
-                <a:spcPts val="900"/>
+                <a:spcPts val="1800"/>
               </a:spcBef>
               <a:buNone/>
             </a:pPr>
             <a:r>
-              <a:rPr lang="vi" sz="1800" b="1" dirty="0">
-                <a:solidFill>
-                  <a:schemeClr val="accent1"/>
-                </a:solidFill>
-                <a:latin typeface="+mn-lt"/>
-                <a:ea typeface="+mn-ea"/>
-                <a:cs typeface="+mn-cs"/>
-              </a:rPr>
-              <a:t>Lưu ý:</a:t>
-            </a:r>
-            <a:r>
-              <a:rPr lang="vi" sz="1800" dirty="0">
-                <a:solidFill>
-                  <a:schemeClr val="dk1"/>
-                </a:solidFill>
-                <a:latin typeface="+mn-lt"/>
-                <a:ea typeface="+mn-ea"/>
-                <a:cs typeface="+mn-cs"/>
-              </a:rPr>
-              <a:t> persona là giả định của nhóm (giả định, chưa kiểm chứng với người dùng thật)</a:t>
+              <a:rPr lang="vi" sz="2400" dirty="0" b="1">
+                <a:solidFill>
+                  <a:srgbClr val="1A56C8"/>
+                </a:solidFill>
+                <a:latin typeface="+mn-lt"/>
+                <a:ea typeface="+mn-ea"/>
+                <a:cs typeface="+mn-cs"/>
+              </a:rPr>
+              <a:t>Lưu ý: </a:t>
+            </a:r>
+            <a:r>
+              <a:rPr lang="vi" sz="2400" dirty="0">
+                <a:solidFill>
+                  <a:srgbClr val="1C1B18"/>
+                </a:solidFill>
+                <a:latin typeface="+mn-lt"/>
+                <a:ea typeface="+mn-ea"/>
+                <a:cs typeface="+mn-cs"/>
+              </a:rPr>
+              <a:t>persona là giả định của nhóm, chưa kiểm chứng với người dùng thật</a:t>
             </a:r>
           </a:p>
         </p:txBody>
@@ -4228,7 +4124,7 @@
               <a:avLst/>
             </a:prstGeom>
             <a:solidFill>
-              <a:schemeClr val="accent1"/>
+              <a:srgbClr val="1A56C8"/>
             </a:solidFill>
             <a:ln>
               <a:noFill/>
@@ -4284,9 +4180,9 @@
             <a:p>
               <a:pPr algn="l"/>
               <a:r>
-                <a:rPr lang="vi" sz="1350" dirty="0">
+                <a:rPr lang="vi" sz="1200" dirty="0">
                   <a:solidFill>
-                    <a:schemeClr val="accent6"/>
+                    <a:srgbClr val="555555"/>
                   </a:solidFill>
                   <a:latin typeface="+mn-lt"/>
                   <a:ea typeface="+mn-ea"/>
@@ -4392,7 +4288,7 @@
         <p:spPr>
           <a:xfrm>
             <a:off x="752856" y="1327150"/>
-            <a:ext cx="7643332" cy="2599944"/>
+            <a:ext cx="9900000" cy="4200000"/>
           </a:xfrm>
           <a:prstGeom prst="rect">
             <a:avLst/>
@@ -4403,148 +4299,126 @@
           </a:ln>
         </p:spPr>
         <p:txBody>
-          <a:bodyPr wrap="none" lIns="0" tIns="0" rIns="0" bIns="0" anchor="t" anchorCtr="0">
+          <a:bodyPr wrap="square" lIns="0" tIns="0" rIns="0" bIns="0" anchor="t" anchorCtr="0">
             <a:noAutofit/>
           </a:bodyPr>
           <a:lstStyle/>
           <a:p>
             <a:pPr marL="0" indent="0" algn="l">
               <a:lnSpc>
-                <a:spcPts val="2550"/>
+                <a:spcPts val="3240"/>
               </a:lnSpc>
               <a:buNone/>
             </a:pPr>
             <a:r>
-              <a:rPr lang="vi" sz="1800" dirty="0">
-                <a:solidFill>
-                  <a:schemeClr val="dk1"/>
-                </a:solidFill>
-                <a:latin typeface="+mn-lt"/>
-                <a:ea typeface="+mn-ea"/>
-                <a:cs typeface="+mn-cs"/>
-              </a:rPr>
-              <a:t>25 màn hình S1-S25; thanh điều hướng 3 tab: </a:t>
-            </a:r>
-            <a:r>
-              <a:rPr lang="vi" sz="1800" b="1" dirty="0">
-                <a:solidFill>
-                  <a:schemeClr val="accent1"/>
-                </a:solidFill>
-                <a:latin typeface="+mn-lt"/>
-                <a:ea typeface="+mn-ea"/>
-                <a:cs typeface="+mn-cs"/>
-              </a:rPr>
-              <a:t>Classes, Proposals, Profile</a:t>
+              <a:rPr lang="vi" sz="2400" dirty="0">
+                <a:solidFill>
+                  <a:srgbClr val="1C1B18"/>
+                </a:solidFill>
+                <a:latin typeface="+mn-lt"/>
+                <a:ea typeface="+mn-ea"/>
+                <a:cs typeface="+mn-cs"/>
+              </a:rPr>
+              <a:t>25 màn hình, thanh điều hướng 3 tab: Classes, Proposals, Profile</a:t>
             </a:r>
           </a:p>
           <a:p>
             <a:pPr marL="0" indent="0" algn="l">
               <a:lnSpc>
-                <a:spcPts val="2550"/>
+                <a:spcPts val="3240"/>
               </a:lnSpc>
               <a:spcBef>
-                <a:spcPts val="1650"/>
+                <a:spcPts val="1800"/>
               </a:spcBef>
               <a:buNone/>
             </a:pPr>
             <a:r>
-              <a:rPr lang="vi" sz="1800" b="1" dirty="0">
-                <a:solidFill>
-                  <a:schemeClr val="accent1"/>
-                </a:solidFill>
-                <a:latin typeface="+mn-lt"/>
-                <a:ea typeface="+mn-ea"/>
-                <a:cs typeface="+mn-cs"/>
-              </a:rPr>
-              <a:t>Classes (S2)</a:t>
-            </a:r>
-            <a:r>
-              <a:rPr lang="vi" sz="1800" dirty="0">
-                <a:solidFill>
-                  <a:schemeClr val="dk1"/>
-                </a:solidFill>
-                <a:latin typeface="+mn-lt"/>
-                <a:ea typeface="+mn-ea"/>
-                <a:cs typeface="+mn-cs"/>
-              </a:rPr>
-              <a:t> → Class detail (S3) → </a:t>
-            </a:r>
-            <a:r>
-              <a:rPr lang="vi" sz="1800" dirty="0">
-                <a:solidFill>
-                  <a:schemeClr val="dk1"/>
-                </a:solidFill>
-                <a:latin typeface="+mn-lt"/>
-                <a:ea typeface="+mn-ea"/>
-                <a:cs typeface="+mn-cs"/>
-              </a:rPr>
-              <a:t>No team (S4), Need members (S5), Student detail (S7)</a:t>
+              <a:rPr lang="vi" sz="2400" dirty="0" b="1">
+                <a:solidFill>
+                  <a:srgbClr val="1A56C8"/>
+                </a:solidFill>
+                <a:latin typeface="+mn-lt"/>
+                <a:ea typeface="+mn-ea"/>
+                <a:cs typeface="+mn-cs"/>
+              </a:rPr>
+              <a:t>Classes: </a:t>
+            </a:r>
+            <a:r>
+              <a:rPr lang="vi" sz="2400" dirty="0">
+                <a:solidFill>
+                  <a:srgbClr val="1C1B18"/>
+                </a:solidFill>
+                <a:latin typeface="+mn-lt"/>
+                <a:ea typeface="+mn-ea"/>
+                <a:cs typeface="+mn-cs"/>
+              </a:rPr>
+              <a:t>S2 → Class detail S3 → No team S4 / Need members S5 → Student detail S7; nhập lớp S22-S23</a:t>
             </a:r>
           </a:p>
           <a:p>
             <a:pPr marL="0" indent="0" algn="l">
               <a:lnSpc>
-                <a:spcPts val="2550"/>
+                <a:spcPts val="3240"/>
               </a:lnSpc>
               <a:spcBef>
-                <a:spcPts val="1650"/>
+                <a:spcPts val="1800"/>
               </a:spcBef>
               <a:buNone/>
             </a:pPr>
             <a:r>
-              <a:rPr lang="vi" sz="1800" b="1" dirty="0">
-                <a:solidFill>
-                  <a:schemeClr val="accent3"/>
-                </a:solidFill>
-                <a:latin typeface="+mn-lt"/>
-                <a:ea typeface="+mn-ea"/>
-                <a:cs typeface="+mn-cs"/>
-              </a:rPr>
-              <a:t>Proposals (S9)</a:t>
-            </a:r>
-            <a:r>
-              <a:rPr lang="vi" sz="1800" dirty="0">
-                <a:solidFill>
-                  <a:schemeClr val="dk1"/>
-                </a:solidFill>
-                <a:latin typeface="+mn-lt"/>
-                <a:ea typeface="+mn-ea"/>
-                <a:cs typeface="+mn-cs"/>
-              </a:rPr>
-              <a:t> → Proposal detail (S10) → Add member (S11) → </a:t>
-            </a:r>
-            <a:r>
-              <a:rPr lang="vi" sz="1800" dirty="0">
-                <a:solidFill>
-                  <a:schemeClr val="dk1"/>
-                </a:solidFill>
-                <a:latin typeface="+mn-lt"/>
-                <a:ea typeface="+mn-ea"/>
-                <a:cs typeface="+mn-cs"/>
-              </a:rPr>
-              <a:t>Approve dialog (S12) / Discard dialog (S17)</a:t>
+              <a:rPr lang="vi" sz="2400" dirty="0" b="1">
+                <a:solidFill>
+                  <a:srgbClr val="1A56C8"/>
+                </a:solidFill>
+                <a:latin typeface="+mn-lt"/>
+                <a:ea typeface="+mn-ea"/>
+                <a:cs typeface="+mn-cs"/>
+              </a:rPr>
+              <a:t>Proposals: </a:t>
+            </a:r>
+            <a:r>
+              <a:rPr lang="vi" sz="2400" dirty="0">
+                <a:solidFill>
+                  <a:srgbClr val="1C1B18"/>
+                </a:solidFill>
+                <a:latin typeface="+mn-lt"/>
+                <a:ea typeface="+mn-ea"/>
+                <a:cs typeface="+mn-cs"/>
+              </a:rPr>
+              <a:t>S9 → Proposal detail S10 → Add member S11 → Approve S12 / Discard S17; bỏ thành viên S24, chặn duyệt S25</a:t>
             </a:r>
           </a:p>
           <a:p>
             <a:pPr marL="0" indent="0" algn="l">
               <a:lnSpc>
-                <a:spcPts val="2550"/>
+                <a:spcPts val="3240"/>
               </a:lnSpc>
               <a:spcBef>
-                <a:spcPts val="1650"/>
+                <a:spcPts val="1800"/>
               </a:spcBef>
               <a:buNone/>
             </a:pPr>
             <a:r>
-              <a:rPr lang="vi" sz="1800" dirty="0">
-                <a:solidFill>
-                  <a:schemeClr val="dk1"/>
-                </a:solidFill>
-                <a:latin typeface="+mn-lt"/>
-                <a:ea typeface="+mn-ea"/>
-                <a:cs typeface="+mn-cs"/>
-              </a:rPr>
-              <a:t>Mỗi màn thuộc ít nhất một flow (S6 Profile là tab gốc; S19-S21 là đường lỗi và nhánh ghép tay)</a:t>
+              <a:rPr lang="vi" sz="2400" dirty="0" b="1">
+                <a:solidFill>
+                  <a:srgbClr val="1A56C8"/>
+                </a:solidFill>
+                <a:latin typeface="+mn-lt"/>
+                <a:ea typeface="+mn-ea"/>
+                <a:cs typeface="+mn-cs"/>
+              </a:rPr>
+              <a:t>Lỗi và ghép tay: </a:t>
+            </a:r>
+            <a:r>
+              <a:rPr lang="vi" sz="2400" dirty="0">
+                <a:solidFill>
+                  <a:srgbClr val="1C1B18"/>
+                </a:solidFill>
+                <a:latin typeface="+mn-lt"/>
+                <a:ea typeface="+mn-ea"/>
+                <a:cs typeface="+mn-cs"/>
+              </a:rPr>
+              <a:t>S13, S15, S16, S18-S21</a:t>
             </a:r>
           </a:p>
         </p:txBody>
@@ -4578,7 +4452,7 @@
               <a:avLst/>
             </a:prstGeom>
             <a:solidFill>
-              <a:schemeClr val="accent1"/>
+              <a:srgbClr val="1A56C8"/>
             </a:solidFill>
             <a:ln>
               <a:noFill/>
@@ -4634,9 +4508,9 @@
             <a:p>
               <a:pPr algn="l"/>
               <a:r>
-                <a:rPr lang="vi" sz="1350" dirty="0">
+                <a:rPr lang="vi" sz="1200" dirty="0">
                   <a:solidFill>
-                    <a:schemeClr val="accent6"/>
+                    <a:srgbClr val="555555"/>
                   </a:solidFill>
                   <a:latin typeface="+mn-lt"/>
                   <a:ea typeface="+mn-ea"/>
@@ -4742,7 +4616,7 @@
         <p:spPr>
           <a:xfrm>
             <a:off x="752856" y="5753100"/>
-            <a:ext cx="4336736" cy="352044"/>
+            <a:ext cx="9900000" cy="352044"/>
           </a:xfrm>
           <a:prstGeom prst="rect">
             <a:avLst/>
@@ -4753,24 +4627,27 @@
           </a:ln>
         </p:spPr>
         <p:txBody>
-          <a:bodyPr wrap="none" lIns="0" tIns="0" rIns="0" bIns="0" anchor="t" anchorCtr="0">
+          <a:bodyPr wrap="square" lIns="0" tIns="0" rIns="0" bIns="0" anchor="t" anchorCtr="0">
             <a:spAutoFit/>
           </a:bodyPr>
           <a:lstStyle/>
           <a:p>
             <a:pPr marL="0" indent="0" algn="l">
+              <a:lnSpc>
+                <a:spcPts val="2430"/>
+              </a:lnSpc>
               <a:buNone/>
             </a:pPr>
             <a:r>
               <a:rPr lang="vi" sz="1800" dirty="0">
                 <a:solidFill>
-                  <a:schemeClr val="dk1"/>
-                </a:solidFill>
-                <a:latin typeface="+mn-lt"/>
-                <a:ea typeface="+mn-ea"/>
-                <a:cs typeface="+mn-cs"/>
-              </a:rPr>
-              <a:t>Bảng flow → màn có trong user-flow.md</a:t>
+                  <a:srgbClr val="1C1B18"/>
+                </a:solidFill>
+                <a:latin typeface="+mn-lt"/>
+                <a:ea typeface="+mn-ea"/>
+                <a:cs typeface="+mn-cs"/>
+              </a:rPr>
+              <a:t>Mỗi flow có đường lỗi và cách phục hồi</a:t>
             </a:r>
           </a:p>
         </p:txBody>
@@ -4804,7 +4681,7 @@
               <a:avLst/>
             </a:prstGeom>
             <a:solidFill>
-              <a:schemeClr val="accent3"/>
+              <a:srgbClr val="1A56C8"/>
             </a:solidFill>
             <a:ln>
               <a:noFill/>
@@ -4842,7 +4719,7 @@
             <p:nvPr/>
           </p:nvPicPr>
           <p:blipFill>
-            <a:blip r:embed="rId3"/>
+            <a:blip r:embed="rId6"/>
             <a:srcRect/>
             <a:stretch>
               <a:fillRect/>
@@ -4883,65 +4760,33 @@
             </a:bodyPr>
             <a:lstStyle/>
             <a:p>
-              <a:pPr algn="l">
+              <a:pPr marL="0" indent="0" algn="l">
                 <a:lnSpc>
-                  <a:spcPts val="2250"/>
+                  <a:spcPts val="2080"/>
                 </a:lnSpc>
+                <a:buNone/>
               </a:pPr>
               <a:r>
-                <a:rPr lang="vi" sz="1400" b="1" dirty="0">
+                <a:rPr lang="vi" sz="1600" dirty="0" b="1">
                   <a:solidFill>
-                    <a:schemeClr val="accent1"/>
+                    <a:srgbClr val="1A56C8"/>
                   </a:solidFill>
                   <a:latin typeface="+mn-lt"/>
                   <a:ea typeface="+mn-ea"/>
                   <a:cs typeface="+mn-cs"/>
                 </a:rPr>
-                <a:t>Flow A:</a:t>
+                <a:t>Flow A: </a:t>
               </a:r>
               <a:r>
-                <a:rPr lang="vi" sz="1400" dirty="0">
+                <a:rPr lang="vi" sz="1600" dirty="0">
                   <a:solidFill>
-                    <a:schemeClr val="dk1"/>
+                    <a:srgbClr val="1C1B18"/>
                   </a:solidFill>
                   <a:latin typeface="+mn-lt"/>
                   <a:ea typeface="+mn-ea"/>
                   <a:cs typeface="+mn-cs"/>
                 </a:rPr>
-                <a:t> duyệt gợi ý AI </a:t>
-              </a:r>
-              <a:r>
-                <a:rPr lang="vi" sz="1400" dirty="0">
-                  <a:solidFill>
-                    <a:schemeClr val="dk1"/>
-                  </a:solidFill>
-                  <a:latin typeface="+mn-lt"/>
-                  <a:ea typeface="+mn-ea"/>
-                  <a:cs typeface="+mn-cs"/>
-                </a:rPr>
-                <a:t>cho một lớp. Lỗi: email </a:t>
-              </a:r>
-              <a:r>
-                <a:rPr lang="vi" sz="1400" dirty="0">
-                  <a:solidFill>
-                    <a:schemeClr val="dk1"/>
-                  </a:solidFill>
-                  <a:latin typeface="+mn-lt"/>
-                  <a:ea typeface="+mn-ea"/>
-                  <a:cs typeface="+mn-cs"/>
-                </a:rPr>
-                <a:t>sai (S19), mất mạng khi AI </a:t>
-              </a:r>
-              <a:r>
-                <a:rPr lang="vi" sz="1400" dirty="0">
-                  <a:solidFill>
-                    <a:schemeClr val="dk1"/>
-                  </a:solidFill>
-                  <a:latin typeface="+mn-lt"/>
-                  <a:ea typeface="+mn-ea"/>
-                  <a:cs typeface="+mn-cs"/>
-                </a:rPr>
-                <a:t>chạy (S18, nút Try again)</a:t>
+                <a:t>duyệt gợi ý AI. Lỗi: email sai (S19), mất mạng (S18). Nhánh: nhập lớp (S22-S23)</a:t>
               </a:r>
             </a:p>
           </p:txBody>
@@ -4970,7 +4815,7 @@
             <p:nvPr/>
           </p:nvPicPr>
           <p:blipFill>
-            <a:blip r:embed="rId4"/>
+            <a:blip r:embed="rId7"/>
             <a:srcRect/>
             <a:stretch>
               <a:fillRect/>
@@ -5011,65 +4856,33 @@
             </a:bodyPr>
             <a:lstStyle/>
             <a:p>
-              <a:pPr algn="l">
+              <a:pPr marL="0" indent="0" algn="l">
                 <a:lnSpc>
-                  <a:spcPts val="2250"/>
+                  <a:spcPts val="2080"/>
                 </a:lnSpc>
+                <a:buNone/>
               </a:pPr>
               <a:r>
-                <a:rPr lang="vi" sz="1400" b="1" dirty="0">
+                <a:rPr lang="vi" sz="1600" dirty="0" b="1">
                   <a:solidFill>
-                    <a:schemeClr val="accent3"/>
+                    <a:srgbClr val="1A56C8"/>
                   </a:solidFill>
                   <a:latin typeface="+mn-lt"/>
                   <a:ea typeface="+mn-ea"/>
                   <a:cs typeface="+mn-cs"/>
                 </a:rPr>
-                <a:t>Flow B:</a:t>
+                <a:t>Flow B: </a:t>
               </a:r>
               <a:r>
-                <a:rPr lang="vi" sz="1400" dirty="0">
+                <a:rPr lang="vi" sz="1600" dirty="0">
                   <a:solidFill>
-                    <a:schemeClr val="dk1"/>
+                    <a:srgbClr val="1C1B18"/>
                   </a:solidFill>
                   <a:latin typeface="+mn-lt"/>
                   <a:ea typeface="+mn-ea"/>
                   <a:cs typeface="+mn-cs"/>
                 </a:rPr>
-                <a:t> thêm thành viên </a:t>
-              </a:r>
-              <a:r>
-                <a:rPr lang="vi" sz="1400" dirty="0">
-                  <a:solidFill>
-                    <a:schemeClr val="dk1"/>
-                  </a:solidFill>
-                  <a:latin typeface="+mn-lt"/>
-                  <a:ea typeface="+mn-ea"/>
-                  <a:cs typeface="+mn-cs"/>
-                </a:rPr>
-                <a:t>vào đề xuất. Lỗi: vượt 6 </a:t>
-              </a:r>
-              <a:r>
-                <a:rPr lang="vi" sz="1400" dirty="0">
-                  <a:solidFill>
-                    <a:schemeClr val="dk1"/>
-                  </a:solidFill>
-                  <a:latin typeface="+mn-lt"/>
-                  <a:ea typeface="+mn-ea"/>
-                  <a:cs typeface="+mn-cs"/>
-                </a:rPr>
-                <a:t>người (S13, "Max 6 </a:t>
-              </a:r>
-              <a:r>
-                <a:rPr lang="vi" sz="1400" dirty="0">
-                  <a:solidFill>
-                    <a:schemeClr val="dk1"/>
-                  </a:solidFill>
-                  <a:latin typeface="+mn-lt"/>
-                  <a:ea typeface="+mn-ea"/>
-                  <a:cs typeface="+mn-cs"/>
-                </a:rPr>
-                <a:t>members")</a:t>
+                <a:t>thêm hoặc bỏ thành viên. Lỗi: quá 6 người (S13), dưới 5 người (S25). Bỏ: S24</a:t>
               </a:r>
             </a:p>
           </p:txBody>
@@ -5139,76 +4952,33 @@
             </a:bodyPr>
             <a:lstStyle/>
             <a:p>
-              <a:pPr algn="l">
+              <a:pPr marL="0" indent="0" algn="l">
                 <a:lnSpc>
-                  <a:spcPts val="2250"/>
+                  <a:spcPts val="2080"/>
                 </a:lnSpc>
+                <a:buNone/>
               </a:pPr>
               <a:r>
-                <a:rPr lang="vi" sz="1400" b="1" dirty="0">
+                <a:rPr lang="vi" sz="1600" dirty="0" b="1">
                   <a:solidFill>
-                    <a:schemeClr val="accent5"/>
+                    <a:srgbClr val="1A56C8"/>
                   </a:solidFill>
                   <a:latin typeface="+mn-lt"/>
                   <a:ea typeface="+mn-ea"/>
                   <a:cs typeface="+mn-cs"/>
                 </a:rPr>
-                <a:t>Flow C:</a:t>
+                <a:t>Flow C: </a:t>
               </a:r>
               <a:r>
-                <a:rPr lang="vi" sz="1400" dirty="0">
+                <a:rPr lang="vi" sz="1600" dirty="0">
                   <a:solidFill>
-                    <a:schemeClr val="dk1"/>
+                    <a:srgbClr val="1C1B18"/>
                   </a:solidFill>
                   <a:latin typeface="+mn-lt"/>
                   <a:ea typeface="+mn-ea"/>
                   <a:cs typeface="+mn-cs"/>
                 </a:rPr>
-                <a:t> AI không ghép </a:t>
-              </a:r>
-              <a:r>
-                <a:rPr lang="vi" sz="1400" dirty="0">
-                  <a:solidFill>
-                    <a:schemeClr val="dk1"/>
-                  </a:solidFill>
-                  <a:latin typeface="+mn-lt"/>
-                  <a:ea typeface="+mn-ea"/>
-                  <a:cs typeface="+mn-cs"/>
-                </a:rPr>
-                <a:t>được, mentor ghép tay. Lỗi: </a:t>
-              </a:r>
-              <a:r>
-                <a:rPr lang="vi" sz="1400" dirty="0">
-                  <a:solidFill>
-                    <a:schemeClr val="dk1"/>
-                  </a:solidFill>
-                  <a:latin typeface="+mn-lt"/>
-                  <a:ea typeface="+mn-ea"/>
-                  <a:cs typeface="+mn-cs"/>
-                </a:rPr>
-                <a:t>sinh viên đã có nhóm bị </a:t>
-              </a:r>
-              <a:r>
-                <a:rPr lang="vi" sz="1400" dirty="0">
-                  <a:solidFill>
-                    <a:schemeClr val="dk1"/>
-                  </a:solidFill>
-                  <a:latin typeface="+mn-lt"/>
-                  <a:ea typeface="+mn-ea"/>
-                  <a:cs typeface="+mn-cs"/>
-                </a:rPr>
-                <a:t>khóa (S16), tìm không ra (S21); hủy đề xuất </a:t>
-              </a:r>
-              <a:r>
-                <a:rPr lang="vi" sz="1400" dirty="0">
-                  <a:solidFill>
-                    <a:schemeClr val="dk1"/>
-                  </a:solidFill>
-                  <a:latin typeface="+mn-lt"/>
-                  <a:ea typeface="+mn-ea"/>
-                  <a:cs typeface="+mn-cs"/>
-                </a:rPr>
-                <a:t>bằng Discard (S17)</a:t>
+                <a:t>mentor ghép tay. Lỗi: sinh viên đã có nhóm (S16), không tìm thấy (S21). Hủy: S17</a:t>
               </a:r>
             </a:p>
           </p:txBody>
@@ -5255,9 +5025,9 @@
             <a:p>
               <a:pPr algn="l"/>
               <a:r>
-                <a:rPr lang="vi" sz="1350" dirty="0">
+                <a:rPr lang="vi" sz="1200" dirty="0">
                   <a:solidFill>
-                    <a:schemeClr val="accent6"/>
+                    <a:srgbClr val="555555"/>
                   </a:solidFill>
                   <a:latin typeface="+mn-lt"/>
                   <a:ea typeface="+mn-ea"/>
@@ -5363,7 +5133,7 @@
         <p:spPr>
           <a:xfrm>
             <a:off x="752856" y="1327150"/>
-            <a:ext cx="4249263" cy="3609594"/>
+            <a:ext cx="5600000" cy="4400000"/>
           </a:xfrm>
           <a:prstGeom prst="rect">
             <a:avLst/>
@@ -5374,200 +5144,126 @@
           </a:ln>
         </p:spPr>
         <p:txBody>
-          <a:bodyPr wrap="none" lIns="0" tIns="0" rIns="0" bIns="0" anchor="t" anchorCtr="0">
+          <a:bodyPr wrap="square" lIns="0" tIns="0" rIns="0" bIns="0" anchor="t" anchorCtr="0">
             <a:noAutofit/>
           </a:bodyPr>
           <a:lstStyle/>
           <a:p>
             <a:pPr marL="0" indent="0" algn="l">
               <a:lnSpc>
-                <a:spcPts val="2550"/>
+                <a:spcPts val="2700"/>
               </a:lnSpc>
               <a:buNone/>
             </a:pPr>
             <a:r>
-              <a:rPr lang="vi" sz="1600" b="1" dirty="0">
-                <a:solidFill>
-                  <a:schemeClr val="accent3"/>
-                </a:solidFill>
-                <a:latin typeface="+mn-lt"/>
-                <a:ea typeface="+mn-ea"/>
-                <a:cs typeface="+mn-cs"/>
-              </a:rPr>
-              <a:t>Prompt gồm:</a:t>
-            </a:r>
-            <a:r>
-              <a:rPr lang="vi" sz="1600" dirty="0">
-                <a:solidFill>
-                  <a:schemeClr val="dk1"/>
-                </a:solidFill>
-                <a:latin typeface="+mn-lt"/>
-                <a:ea typeface="+mn-ea"/>
-                <a:cs typeface="+mn-cs"/>
-              </a:rPr>
-              <a:t> người dùng (mentor), </a:t>
-            </a:r>
-            <a:r>
-              <a:rPr lang="vi" sz="1600" dirty="0">
-                <a:solidFill>
-                  <a:schemeClr val="dk1"/>
-                </a:solidFill>
-                <a:latin typeface="+mn-lt"/>
-                <a:ea typeface="+mn-ea"/>
-                <a:cs typeface="+mn-cs"/>
-              </a:rPr>
-              <a:t>tác vụ (duyệt gợi ý AI), nền tảng </a:t>
-            </a:r>
-            <a:r>
-              <a:rPr lang="vi" sz="1600" dirty="0">
-                <a:solidFill>
-                  <a:schemeClr val="dk1"/>
-                </a:solidFill>
-                <a:latin typeface="+mn-lt"/>
-                <a:ea typeface="+mn-ea"/>
-                <a:cs typeface="+mn-cs"/>
-              </a:rPr>
-              <a:t>(Android 360×800, Material 3), </a:t>
-            </a:r>
-            <a:r>
-              <a:rPr lang="vi" sz="1600" dirty="0">
-                <a:solidFill>
-                  <a:schemeClr val="dk1"/>
-                </a:solidFill>
-                <a:latin typeface="+mn-lt"/>
-                <a:ea typeface="+mn-ea"/>
-                <a:cs typeface="+mn-cs"/>
-              </a:rPr>
-              <a:t>ràng buộc (chữ ≥14 sp, 1 nút chính, </a:t>
-            </a:r>
-            <a:r>
-              <a:rPr lang="vi" sz="1600" dirty="0">
-                <a:solidFill>
-                  <a:schemeClr val="dk1"/>
-                </a:solidFill>
-                <a:latin typeface="+mn-lt"/>
-                <a:ea typeface="+mn-ea"/>
-                <a:cs typeface="+mn-cs"/>
-              </a:rPr>
-              <a:t>không từ cấm), phong cách (DESIGN.md)</a:t>
+              <a:rPr lang="vi" sz="2000" dirty="0">
+                <a:solidFill>
+                  <a:srgbClr val="1C1B18"/>
+                </a:solidFill>
+                <a:latin typeface="+mn-lt"/>
+                <a:ea typeface="+mn-ea"/>
+                <a:cs typeface="+mn-cs"/>
+              </a:rPr>
+              <a:t>Prompt gồm 5 phần: người dùng (mentor), tác vụ, nền tảng (Android 360×800), ràng buộc, phong cách (DESIGN.md)</a:t>
             </a:r>
           </a:p>
           <a:p>
             <a:pPr marL="0" indent="0" algn="l">
               <a:lnSpc>
-                <a:spcPts val="2550"/>
+                <a:spcPts val="2700"/>
               </a:lnSpc>
               <a:spcBef>
-                <a:spcPts val="1350"/>
+                <a:spcPts val="1600"/>
               </a:spcBef>
               <a:buNone/>
             </a:pPr>
             <a:r>
-              <a:rPr lang="vi" sz="1600" b="1" dirty="0">
-                <a:solidFill>
-                  <a:schemeClr val="accent3"/>
-                </a:solidFill>
-                <a:latin typeface="+mn-lt"/>
-                <a:ea typeface="+mn-ea"/>
-                <a:cs typeface="+mn-cs"/>
-              </a:rPr>
-              <a:t>Lần đầu (R0, hướng sinh viên): </a:t>
-            </a:r>
-            <a:r>
-              <a:rPr lang="vi" sz="1600" dirty="0">
-                <a:solidFill>
-                  <a:schemeClr val="dk1"/>
-                </a:solidFill>
-                <a:latin typeface="+mn-lt"/>
-                <a:ea typeface="+mn-ea"/>
-                <a:cs typeface="+mn-cs"/>
-              </a:rPr>
-              <a:t>4 màn, có chữ nội bộ như "Lineup", </a:t>
-            </a:r>
-            <a:r>
-              <a:rPr lang="vi" sz="1600" dirty="0">
-                <a:solidFill>
-                  <a:schemeClr val="dk1"/>
-                </a:solidFill>
-                <a:latin typeface="+mn-lt"/>
-                <a:ea typeface="+mn-ea"/>
-                <a:cs typeface="+mn-cs"/>
-              </a:rPr>
-              <a:t>"Roster"</a:t>
+              <a:rPr lang="vi" sz="2000" dirty="0" b="1">
+                <a:solidFill>
+                  <a:srgbClr val="1A56C8"/>
+                </a:solidFill>
+                <a:latin typeface="+mn-lt"/>
+                <a:ea typeface="+mn-ea"/>
+                <a:cs typeface="+mn-cs"/>
+              </a:rPr>
+              <a:t>R0 (hướng sinh viên): </a:t>
+            </a:r>
+            <a:r>
+              <a:rPr lang="vi" sz="2000" dirty="0">
+                <a:solidFill>
+                  <a:srgbClr val="1C1B18"/>
+                </a:solidFill>
+                <a:latin typeface="+mn-lt"/>
+                <a:ea typeface="+mn-ea"/>
+                <a:cs typeface="+mn-cs"/>
+              </a:rPr>
+              <a:t>4 màn, lẫn chữ nội bộ như "Lineup"</a:t>
             </a:r>
           </a:p>
           <a:p>
             <a:pPr marL="0" indent="0" algn="l">
               <a:lnSpc>
-                <a:spcPts val="2550"/>
+                <a:spcPts val="2700"/>
               </a:lnSpc>
               <a:spcBef>
-                <a:spcPts val="1350"/>
+                <a:spcPts val="1600"/>
               </a:spcBef>
               <a:buNone/>
             </a:pPr>
             <a:r>
-              <a:rPr lang="vi" sz="1600" b="1" dirty="0">
-                <a:solidFill>
-                  <a:schemeClr val="accent3"/>
-                </a:solidFill>
-                <a:latin typeface="+mn-lt"/>
-                <a:ea typeface="+mn-ea"/>
-                <a:cs typeface="+mn-cs"/>
-              </a:rPr>
-              <a:t>Hướng mentor (R9):</a:t>
-            </a:r>
-            <a:r>
-              <a:rPr lang="vi" sz="1600" dirty="0">
-                <a:solidFill>
-                  <a:schemeClr val="dk1"/>
-                </a:solidFill>
-                <a:latin typeface="+mn-lt"/>
-                <a:ea typeface="+mn-ea"/>
-                <a:cs typeface="+mn-cs"/>
-              </a:rPr>
-              <a:t> 3 prompt × 6 </a:t>
-            </a:r>
-            <a:r>
-              <a:rPr lang="vi" sz="1600" dirty="0">
-                <a:solidFill>
-                  <a:schemeClr val="dk1"/>
-                </a:solidFill>
-                <a:latin typeface="+mn-lt"/>
-                <a:ea typeface="+mn-ea"/>
-                <a:cs typeface="+mn-cs"/>
-              </a:rPr>
-              <a:t>frame = 18 frame, xuất sang Figma; R10: 1 prompt</a:t>
-            </a:r>
-            <a:endParaRPr lang="en-US" sz="1800" dirty="0">
-              <a:solidFill>
-                <a:schemeClr val="dk1"/>
-              </a:solidFill>
-              <a:latin typeface="+mn-lt"/>
-              <a:ea typeface="+mn-ea"/>
-              <a:cs typeface="+mn-cs"/>
-            </a:endParaRPr>
+              <a:rPr lang="vi" sz="2000" dirty="0" b="1">
+                <a:solidFill>
+                  <a:srgbClr val="1A56C8"/>
+                </a:solidFill>
+                <a:latin typeface="+mn-lt"/>
+                <a:ea typeface="+mn-ea"/>
+                <a:cs typeface="+mn-cs"/>
+              </a:rPr>
+              <a:t>R9-R10 (hướng mentor): </a:t>
+            </a:r>
+            <a:r>
+              <a:rPr lang="vi" sz="2000" dirty="0">
+                <a:solidFill>
+                  <a:srgbClr val="1C1B18"/>
+                </a:solidFill>
+                <a:latin typeface="+mn-lt"/>
+                <a:ea typeface="+mn-ea"/>
+                <a:cs typeface="+mn-cs"/>
+              </a:rPr>
+              <a:t>21 màn xuất sang Figma</a:t>
+            </a:r>
           </a:p>
           <a:p>
             <a:pPr marL="0" indent="0" algn="l">
               <a:lnSpc>
-                <a:spcPts val="2550"/>
+                <a:spcPts val="2700"/>
               </a:lnSpc>
               <a:spcBef>
-                <a:spcPts val="1350"/>
+                <a:spcPts val="1600"/>
               </a:spcBef>
               <a:buNone/>
             </a:pPr>
             <a:r>
-              <a:rPr lang="vi" sz="1600" dirty="0">
-                <a:solidFill>
-                  <a:schemeClr val="dk1"/>
-                </a:solidFill>
-                <a:latin typeface="+mn-lt"/>
-                <a:ea typeface="+mn-ea"/>
-                <a:cs typeface="+mn-cs"/>
-              </a:rPr>
-              <a:t> 3 frame (S19-S21) = 21 frame</a:t>
+              <a:rPr lang="vi" sz="2000" dirty="0" b="1">
+                <a:solidFill>
+                  <a:srgbClr val="1A56C8"/>
+                </a:solidFill>
+                <a:latin typeface="+mn-lt"/>
+                <a:ea typeface="+mn-ea"/>
+                <a:cs typeface="+mn-cs"/>
+              </a:rPr>
+              <a:t>S22-S25: </a:t>
+            </a:r>
+            <a:r>
+              <a:rPr lang="vi" sz="2000" dirty="0">
+                <a:solidFill>
+                  <a:srgbClr val="1C1B18"/>
+                </a:solidFill>
+                <a:latin typeface="+mn-lt"/>
+                <a:ea typeface="+mn-ea"/>
+                <a:cs typeface="+mn-cs"/>
+              </a:rPr>
+              <a:t>dựng trực tiếp trong Figma</a:t>
             </a:r>
           </a:p>
         </p:txBody>
@@ -5666,7 +5362,7 @@
               <a:avLst/>
             </a:prstGeom>
             <a:solidFill>
-              <a:schemeClr val="accent3"/>
+              <a:srgbClr val="1A56C8"/>
             </a:solidFill>
             <a:ln>
               <a:noFill/>
@@ -5824,9 +5520,9 @@
             <a:p>
               <a:pPr algn="l"/>
               <a:r>
-                <a:rPr lang="vi" sz="1350" dirty="0">
+                <a:rPr lang="vi" sz="1200" dirty="0">
                   <a:solidFill>
-                    <a:schemeClr val="accent6"/>
+                    <a:srgbClr val="555555"/>
                   </a:solidFill>
                   <a:latin typeface="+mn-lt"/>
                   <a:ea typeface="+mn-ea"/>
@@ -5932,7 +5628,7 @@
         <p:spPr>
           <a:xfrm>
             <a:off x="752856" y="1327150"/>
-            <a:ext cx="3789365" cy="4523994"/>
+            <a:ext cx="5600000" cy="4400000"/>
           </a:xfrm>
           <a:prstGeom prst="rect">
             <a:avLst/>
@@ -5943,280 +5639,170 @@
           </a:ln>
         </p:spPr>
         <p:txBody>
-          <a:bodyPr wrap="none" lIns="0" tIns="0" rIns="0" bIns="0" anchor="t" anchorCtr="0">
+          <a:bodyPr wrap="square" lIns="0" tIns="0" rIns="0" bIns="0" anchor="t" anchorCtr="0">
             <a:noAutofit/>
           </a:bodyPr>
           <a:lstStyle/>
           <a:p>
             <a:pPr marL="0" indent="0" algn="l">
               <a:lnSpc>
-                <a:spcPts val="2550"/>
+                <a:spcPts val="2700"/>
               </a:lnSpc>
               <a:buNone/>
             </a:pPr>
             <a:r>
-              <a:rPr lang="vi" sz="1500" b="1" dirty="0">
-                <a:solidFill>
-                  <a:schemeClr val="accent3"/>
-                </a:solidFill>
-                <a:latin typeface="+mn-lt"/>
-                <a:ea typeface="+mn-ea"/>
-                <a:cs typeface="+mn-cs"/>
-              </a:rPr>
-              <a:t>R3:</a:t>
-            </a:r>
-            <a:r>
-              <a:rPr lang="vi" sz="1500" dirty="0">
-                <a:solidFill>
-                  <a:schemeClr val="dk1"/>
-                </a:solidFill>
-                <a:latin typeface="+mn-lt"/>
-                <a:ea typeface="+mn-ea"/>
-                <a:cs typeface="+mn-cs"/>
-              </a:rPr>
-              <a:t> chú thích đè chữ → bỏ chú thích</a:t>
+              <a:rPr lang="vi" sz="2000" dirty="0" b="1">
+                <a:solidFill>
+                  <a:srgbClr val="1A56C8"/>
+                </a:solidFill>
+                <a:latin typeface="+mn-lt"/>
+                <a:ea typeface="+mn-ea"/>
+                <a:cs typeface="+mn-cs"/>
+              </a:rPr>
+              <a:t>R3: </a:t>
+            </a:r>
+            <a:r>
+              <a:rPr lang="vi" sz="2000" dirty="0">
+                <a:solidFill>
+                  <a:srgbClr val="1C1B18"/>
+                </a:solidFill>
+                <a:latin typeface="+mn-lt"/>
+                <a:ea typeface="+mn-ea"/>
+                <a:cs typeface="+mn-cs"/>
+              </a:rPr>
+              <a:t>chú thích đè chữ → bỏ chú thích</a:t>
             </a:r>
           </a:p>
           <a:p>
             <a:pPr marL="0" indent="0" algn="l">
               <a:lnSpc>
-                <a:spcPts val="2550"/>
+                <a:spcPts val="2700"/>
               </a:lnSpc>
               <a:spcBef>
-                <a:spcPts val="450"/>
+                <a:spcPts val="1600"/>
               </a:spcBef>
               <a:buNone/>
             </a:pPr>
             <a:r>
-              <a:rPr lang="vi" sz="1500" b="1" dirty="0">
-                <a:solidFill>
-                  <a:schemeClr val="accent3"/>
-                </a:solidFill>
-                <a:latin typeface="+mn-lt"/>
-                <a:ea typeface="+mn-ea"/>
-                <a:cs typeface="+mn-cs"/>
-              </a:rPr>
-              <a:t>R4:</a:t>
-            </a:r>
-            <a:r>
-              <a:rPr lang="vi" sz="1500" dirty="0">
-                <a:solidFill>
-                  <a:schemeClr val="dk1"/>
-                </a:solidFill>
-                <a:latin typeface="+mn-lt"/>
-                <a:ea typeface="+mn-ea"/>
-                <a:cs typeface="+mn-cs"/>
-              </a:rPr>
-              <a:t> app bar không nhất quán → </a:t>
-            </a:r>
-            <a:r>
-              <a:rPr lang="vi" sz="1500" dirty="0">
-                <a:solidFill>
-                  <a:schemeClr val="dk1"/>
-                </a:solidFill>
-                <a:latin typeface="+mn-lt"/>
-                <a:ea typeface="+mn-ea"/>
-                <a:cs typeface="+mn-cs"/>
-              </a:rPr>
-              <a:t>thống nhất, giảm chữ</a:t>
+              <a:rPr lang="vi" sz="2000" dirty="0" b="1">
+                <a:solidFill>
+                  <a:srgbClr val="1A56C8"/>
+                </a:solidFill>
+                <a:latin typeface="+mn-lt"/>
+                <a:ea typeface="+mn-ea"/>
+                <a:cs typeface="+mn-cs"/>
+              </a:rPr>
+              <a:t>R4: </a:t>
+            </a:r>
+            <a:r>
+              <a:rPr lang="vi" sz="2000" dirty="0">
+                <a:solidFill>
+                  <a:srgbClr val="1C1B18"/>
+                </a:solidFill>
+                <a:latin typeface="+mn-lt"/>
+                <a:ea typeface="+mn-ea"/>
+                <a:cs typeface="+mn-cs"/>
+              </a:rPr>
+              <a:t>app bar không nhất quán → thống nhất</a:t>
             </a:r>
           </a:p>
           <a:p>
             <a:pPr marL="0" indent="0" algn="l">
               <a:lnSpc>
-                <a:spcPts val="2550"/>
+                <a:spcPts val="2700"/>
               </a:lnSpc>
               <a:spcBef>
-                <a:spcPts val="450"/>
+                <a:spcPts val="1600"/>
               </a:spcBef>
               <a:buNone/>
             </a:pPr>
             <a:r>
-              <a:rPr lang="vi" sz="1500" b="1" dirty="0">
-                <a:solidFill>
-                  <a:schemeClr val="accent3"/>
-                </a:solidFill>
-                <a:latin typeface="+mn-lt"/>
-                <a:ea typeface="+mn-ea"/>
-                <a:cs typeface="+mn-cs"/>
-              </a:rPr>
-              <a:t>R6:</a:t>
-            </a:r>
-            <a:r>
-              <a:rPr lang="vi" sz="1500" dirty="0">
-                <a:solidFill>
-                  <a:schemeClr val="dk1"/>
-                </a:solidFill>
-                <a:latin typeface="+mn-lt"/>
-                <a:ea typeface="+mn-ea"/>
-                <a:cs typeface="+mn-cs"/>
-              </a:rPr>
-              <a:t> email yêu cầu tên miền edu → </a:t>
-            </a:r>
-            <a:r>
-              <a:rPr lang="vi" sz="1500" dirty="0">
-                <a:solidFill>
-                  <a:schemeClr val="dk1"/>
-                </a:solidFill>
-                <a:latin typeface="+mn-lt"/>
-                <a:ea typeface="+mn-ea"/>
-                <a:cs typeface="+mn-cs"/>
-              </a:rPr>
-              <a:t>email bất kỳ</a:t>
+              <a:rPr lang="vi" sz="2000" dirty="0" b="1">
+                <a:solidFill>
+                  <a:srgbClr val="1A56C8"/>
+                </a:solidFill>
+                <a:latin typeface="+mn-lt"/>
+                <a:ea typeface="+mn-ea"/>
+                <a:cs typeface="+mn-cs"/>
+              </a:rPr>
+              <a:t>R6: </a:t>
+            </a:r>
+            <a:r>
+              <a:rPr lang="vi" sz="2000" dirty="0">
+                <a:solidFill>
+                  <a:srgbClr val="1C1B18"/>
+                </a:solidFill>
+                <a:latin typeface="+mn-lt"/>
+                <a:ea typeface="+mn-ea"/>
+                <a:cs typeface="+mn-cs"/>
+              </a:rPr>
+              <a:t>email bắt buộc tên miền edu → email bất kỳ</a:t>
             </a:r>
           </a:p>
           <a:p>
             <a:pPr marL="0" indent="0" algn="l">
               <a:lnSpc>
-                <a:spcPts val="2550"/>
+                <a:spcPts val="2700"/>
               </a:lnSpc>
               <a:spcBef>
-                <a:spcPts val="450"/>
+                <a:spcPts val="1600"/>
               </a:spcBef>
               <a:buNone/>
             </a:pPr>
             <a:r>
-              <a:rPr lang="vi" sz="1500" b="1" dirty="0">
-                <a:solidFill>
-                  <a:schemeClr val="accent3"/>
-                </a:solidFill>
-                <a:latin typeface="+mn-lt"/>
-                <a:ea typeface="+mn-ea"/>
-                <a:cs typeface="+mn-cs"/>
-              </a:rPr>
-              <a:t>R7:</a:t>
-            </a:r>
-            <a:r>
-              <a:rPr lang="vi" sz="1500" dirty="0">
-                <a:solidFill>
-                  <a:schemeClr val="dk1"/>
-                </a:solidFill>
-                <a:latin typeface="+mn-lt"/>
-                <a:ea typeface="+mn-ea"/>
-                <a:cs typeface="+mn-cs"/>
-              </a:rPr>
-              <a:t> thẻ so với nền chỉ 1.07:1 → </a:t>
-            </a:r>
-            <a:r>
-              <a:rPr lang="vi" sz="1500" dirty="0">
-                <a:solidFill>
-                  <a:schemeClr val="dk1"/>
-                </a:solidFill>
-                <a:latin typeface="+mn-lt"/>
-                <a:ea typeface="+mn-ea"/>
-                <a:cs typeface="+mn-cs"/>
-              </a:rPr>
-              <a:t>palette cam, xanh lá, viền thẻ rõ</a:t>
+              <a:rPr lang="vi" sz="2000" dirty="0" b="1">
+                <a:solidFill>
+                  <a:srgbClr val="1A56C8"/>
+                </a:solidFill>
+                <a:latin typeface="+mn-lt"/>
+                <a:ea typeface="+mn-ea"/>
+                <a:cs typeface="+mn-cs"/>
+              </a:rPr>
+              <a:t>R7: </a:t>
+            </a:r>
+            <a:r>
+              <a:rPr lang="vi" sz="2000" dirty="0">
+                <a:solidFill>
+                  <a:srgbClr val="1C1B18"/>
+                </a:solidFill>
+                <a:latin typeface="+mn-lt"/>
+                <a:ea typeface="+mn-ea"/>
+                <a:cs typeface="+mn-cs"/>
+              </a:rPr>
+              <a:t>thẻ chìm vào nền (1.07:1) → đổi palette, viền thẻ rõ</a:t>
             </a:r>
           </a:p>
           <a:p>
             <a:pPr marL="0" indent="0" algn="l">
               <a:lnSpc>
-                <a:spcPts val="2550"/>
+                <a:spcPts val="2700"/>
               </a:lnSpc>
               <a:spcBef>
-                <a:spcPts val="450"/>
+                <a:spcPts val="1600"/>
               </a:spcBef>
               <a:buNone/>
             </a:pPr>
             <a:r>
-              <a:rPr lang="vi" sz="1500" b="1" dirty="0">
-                <a:solidFill>
-                  <a:schemeClr val="accent3"/>
-                </a:solidFill>
-                <a:latin typeface="+mn-lt"/>
-                <a:ea typeface="+mn-ea"/>
-                <a:cs typeface="+mn-cs"/>
-              </a:rPr>
-              <a:t>R9→Figma:</a:t>
-            </a:r>
-            <a:r>
-              <a:rPr lang="vi" sz="1500" dirty="0">
-                <a:solidFill>
-                  <a:schemeClr val="dk1"/>
-                </a:solidFill>
-                <a:latin typeface="+mn-lt"/>
-                <a:ea typeface="+mn-ea"/>
-                <a:cs typeface="+mn-cs"/>
-              </a:rPr>
-              <a:t> S4 chữ Stitch tự thêm; </a:t>
-            </a:r>
-            <a:r>
-              <a:rPr lang="vi" sz="1500" dirty="0">
-                <a:solidFill>
-                  <a:schemeClr val="dk1"/>
-                </a:solidFill>
-                <a:latin typeface="+mn-lt"/>
-                <a:ea typeface="+mn-ea"/>
-                <a:cs typeface="+mn-cs"/>
-              </a:rPr>
-              <a:t>S17 nền sai → sửa S4 và S17</a:t>
-            </a:r>
-          </a:p>
-          <a:p>
-            <a:pPr marL="0" indent="0" algn="l">
-              <a:lnSpc>
-                <a:spcPts val="2550"/>
-              </a:lnSpc>
-              <a:spcBef>
-                <a:spcPts val="450"/>
-              </a:spcBef>
-              <a:buNone/>
-            </a:pPr>
-            <a:r>
-              <a:rPr lang="vi" sz="1500" b="1" dirty="0">
-                <a:solidFill>
-                  <a:schemeClr val="accent1"/>
-                </a:solidFill>
-                <a:latin typeface="+mn-lt"/>
-                <a:ea typeface="+mn-ea"/>
-                <a:cs typeface="+mn-cs"/>
-              </a:rPr>
-              <a:t>Findings (≥5, gắn màn):</a:t>
-            </a:r>
-            <a:r>
-              <a:rPr lang="vi" sz="1500" dirty="0">
-                <a:solidFill>
-                  <a:schemeClr val="dk1"/>
-                </a:solidFill>
-                <a:latin typeface="+mn-lt"/>
-                <a:ea typeface="+mn-ea"/>
-                <a:cs typeface="+mn-cs"/>
-              </a:rPr>
-              <a:t> S4 chữ bịa; </a:t>
-            </a:r>
-            <a:r>
-              <a:rPr lang="vi" sz="1500" dirty="0">
-                <a:solidFill>
-                  <a:schemeClr val="dk1"/>
-                </a:solidFill>
-                <a:latin typeface="+mn-lt"/>
-                <a:ea typeface="+mn-ea"/>
-                <a:cs typeface="+mn-cs"/>
-              </a:rPr>
-              <a:t>S17 nền sai; S9 badge 10 sp; </a:t>
-            </a:r>
-            <a:r>
-              <a:rPr lang="vi" sz="1500" dirty="0">
-                <a:solidFill>
-                  <a:schemeClr val="dk1"/>
-                </a:solidFill>
-                <a:latin typeface="+mn-lt"/>
-                <a:ea typeface="+mn-ea"/>
-                <a:cs typeface="+mn-cs"/>
-              </a:rPr>
-              <a:t>S2/S12/S13 cao hơn 800 dp; </a:t>
-            </a:r>
-            <a:r>
-              <a:rPr lang="vi" sz="1500" dirty="0">
-                <a:solidFill>
-                  <a:schemeClr val="dk1"/>
-                </a:solidFill>
-                <a:latin typeface="+mn-lt"/>
-                <a:ea typeface="+mn-ea"/>
-                <a:cs typeface="+mn-cs"/>
-              </a:rPr>
-              <a:t>viền thẻ 1.48:1</a:t>
+              <a:rPr lang="vi" sz="2000" dirty="0" b="1">
+                <a:solidFill>
+                  <a:srgbClr val="1A56C8"/>
+                </a:solidFill>
+                <a:latin typeface="+mn-lt"/>
+                <a:ea typeface="+mn-ea"/>
+                <a:cs typeface="+mn-cs"/>
+              </a:rPr>
+              <a:t>R9 → Figma: </a:t>
+            </a:r>
+            <a:r>
+              <a:rPr lang="vi" sz="2000" dirty="0">
+                <a:solidFill>
+                  <a:srgbClr val="1C1B18"/>
+                </a:solidFill>
+                <a:latin typeface="+mn-lt"/>
+                <a:ea typeface="+mn-ea"/>
+                <a:cs typeface="+mn-cs"/>
+              </a:rPr>
+              <a:t>S4 chữ bịa, S17 nền sai → sửa trong Figma</a:t>
             </a:r>
           </a:p>
         </p:txBody>
@@ -6417,7 +6003,7 @@
               <a:avLst/>
             </a:prstGeom>
             <a:solidFill>
-              <a:schemeClr val="accent3"/>
+              <a:srgbClr val="1A56C8"/>
             </a:solidFill>
             <a:ln>
               <a:noFill/>
@@ -6470,9 +6056,9 @@
             <a:p>
               <a:pPr algn="l"/>
               <a:r>
-                <a:rPr lang="vi" sz="1350" dirty="0">
+                <a:rPr lang="vi" sz="1200" dirty="0">
                   <a:solidFill>
-                    <a:schemeClr val="accent6"/>
+                    <a:srgbClr val="555555"/>
                   </a:solidFill>
                   <a:latin typeface="+mn-lt"/>
                   <a:ea typeface="+mn-ea"/>
@@ -6578,7 +6164,7 @@
         <p:spPr>
           <a:xfrm>
             <a:off x="752856" y="1422400"/>
-            <a:ext cx="8265033" cy="3038094"/>
+            <a:ext cx="9900000" cy="4200000"/>
           </a:xfrm>
           <a:prstGeom prst="rect">
             <a:avLst/>
@@ -6589,170 +6175,170 @@
           </a:ln>
         </p:spPr>
         <p:txBody>
-          <a:bodyPr wrap="none" lIns="0" tIns="0" rIns="0" bIns="0" anchor="t" anchorCtr="0">
+          <a:bodyPr wrap="square" lIns="0" tIns="0" rIns="0" bIns="0" anchor="t" anchorCtr="0">
             <a:noAutofit/>
           </a:bodyPr>
           <a:lstStyle/>
           <a:p>
             <a:pPr marL="0" indent="0" algn="l">
               <a:lnSpc>
-                <a:spcPts val="2550"/>
+                <a:spcPts val="3240"/>
               </a:lnSpc>
               <a:buNone/>
             </a:pPr>
             <a:r>
-              <a:rPr lang="vi" sz="1800" b="1" dirty="0">
-                <a:solidFill>
-                  <a:schemeClr val="accent5"/>
-                </a:solidFill>
-                <a:latin typeface="+mn-lt"/>
-                <a:ea typeface="+mn-ea"/>
-                <a:cs typeface="+mn-cs"/>
-              </a:rPr>
-              <a:t>Giữ:</a:t>
-            </a:r>
-            <a:r>
-              <a:rPr lang="vi" sz="1800" dirty="0">
-                <a:solidFill>
-                  <a:schemeClr val="dk1"/>
-                </a:solidFill>
-                <a:latin typeface="+mn-lt"/>
-                <a:ea typeface="+mn-ea"/>
-                <a:cs typeface="+mn-cs"/>
-              </a:rPr>
-              <a:t> AI chỉ đề xuất, mentor duyệt (có nhãn mức phù hợp và lý do ngắn)</a:t>
+              <a:rPr lang="vi" sz="2400" dirty="0" b="1">
+                <a:solidFill>
+                  <a:srgbClr val="1A56C8"/>
+                </a:solidFill>
+                <a:latin typeface="+mn-lt"/>
+                <a:ea typeface="+mn-ea"/>
+                <a:cs typeface="+mn-cs"/>
+              </a:rPr>
+              <a:t>Giữ: </a:t>
+            </a:r>
+            <a:r>
+              <a:rPr lang="vi" sz="2400" dirty="0">
+                <a:solidFill>
+                  <a:srgbClr val="1C1B18"/>
+                </a:solidFill>
+                <a:latin typeface="+mn-lt"/>
+                <a:ea typeface="+mn-ea"/>
+                <a:cs typeface="+mn-cs"/>
+              </a:rPr>
+              <a:t>AI chỉ đề xuất, mentor duyệt</a:t>
             </a:r>
           </a:p>
           <a:p>
             <a:pPr marL="0" indent="0" algn="l">
               <a:lnSpc>
-                <a:spcPts val="2550"/>
+                <a:spcPts val="3240"/>
               </a:lnSpc>
               <a:spcBef>
-                <a:spcPts val="2100"/>
+                <a:spcPts val="1800"/>
               </a:spcBef>
               <a:buNone/>
             </a:pPr>
             <a:r>
-              <a:rPr lang="vi" sz="1800" b="1" dirty="0">
-                <a:solidFill>
-                  <a:schemeClr val="accent1"/>
-                </a:solidFill>
-                <a:latin typeface="+mn-lt"/>
-                <a:ea typeface="+mn-ea"/>
-                <a:cs typeface="+mn-cs"/>
-              </a:rPr>
-              <a:t>Sửa:</a:t>
-            </a:r>
-            <a:r>
-              <a:rPr lang="vi" sz="1800" dirty="0">
-                <a:solidFill>
-                  <a:schemeClr val="dk1"/>
-                </a:solidFill>
-                <a:latin typeface="+mn-lt"/>
-                <a:ea typeface="+mn-ea"/>
-                <a:cs typeface="+mn-cs"/>
-              </a:rPr>
-              <a:t> bỏ chú thích dưới ô vai trò vì đè chữ ở 360 dp</a:t>
+              <a:rPr lang="vi" sz="2400" dirty="0" b="1">
+                <a:solidFill>
+                  <a:srgbClr val="1A56C8"/>
+                </a:solidFill>
+                <a:latin typeface="+mn-lt"/>
+                <a:ea typeface="+mn-ea"/>
+                <a:cs typeface="+mn-cs"/>
+              </a:rPr>
+              <a:t>Sửa: </a:t>
+            </a:r>
+            <a:r>
+              <a:rPr lang="vi" sz="2400" dirty="0">
+                <a:solidFill>
+                  <a:srgbClr val="1C1B18"/>
+                </a:solidFill>
+                <a:latin typeface="+mn-lt"/>
+                <a:ea typeface="+mn-ea"/>
+                <a:cs typeface="+mn-cs"/>
+              </a:rPr>
+              <a:t>bỏ chú thích đè chữ ở 360 dp</a:t>
             </a:r>
           </a:p>
           <a:p>
             <a:pPr marL="0" indent="0" algn="l">
               <a:lnSpc>
-                <a:spcPts val="2550"/>
+                <a:spcPts val="3240"/>
               </a:lnSpc>
               <a:spcBef>
-                <a:spcPts val="2100"/>
+                <a:spcPts val="1800"/>
               </a:spcBef>
               <a:buNone/>
             </a:pPr>
             <a:r>
-              <a:rPr lang="vi" sz="1800" b="1" dirty="0">
-                <a:solidFill>
-                  <a:schemeClr val="accent3"/>
-                </a:solidFill>
-                <a:latin typeface="+mn-lt"/>
-                <a:ea typeface="+mn-ea"/>
-                <a:cs typeface="+mn-cs"/>
-              </a:rPr>
-              <a:t>Từ chối:</a:t>
-            </a:r>
-            <a:r>
-              <a:rPr lang="vi" sz="1800" dirty="0">
-                <a:solidFill>
-                  <a:schemeClr val="dk1"/>
-                </a:solidFill>
-                <a:latin typeface="+mn-lt"/>
-                <a:ea typeface="+mn-ea"/>
-                <a:cs typeface="+mn-cs"/>
-              </a:rPr>
-              <a:t> dùng cam FPT #F37021 cho nút (chữ trắng chỉ 2.9:1); chỉ dùng cho logo</a:t>
+              <a:rPr lang="vi" sz="2400" dirty="0" b="1">
+                <a:solidFill>
+                  <a:srgbClr val="1A56C8"/>
+                </a:solidFill>
+                <a:latin typeface="+mn-lt"/>
+                <a:ea typeface="+mn-ea"/>
+                <a:cs typeface="+mn-cs"/>
+              </a:rPr>
+              <a:t>Từ chối: </a:t>
+            </a:r>
+            <a:r>
+              <a:rPr lang="vi" sz="2400" dirty="0">
+                <a:solidFill>
+                  <a:srgbClr val="1C1B18"/>
+                </a:solidFill>
+                <a:latin typeface="+mn-lt"/>
+                <a:ea typeface="+mn-ea"/>
+                <a:cs typeface="+mn-cs"/>
+              </a:rPr>
+              <a:t>cam FPT #F37021 cho nút (chữ trắng chỉ 2.9:1)</a:t>
             </a:r>
           </a:p>
           <a:p>
             <a:pPr marL="0" indent="0" algn="l">
               <a:lnSpc>
-                <a:spcPts val="2550"/>
+                <a:spcPts val="3240"/>
               </a:lnSpc>
               <a:spcBef>
-                <a:spcPts val="2100"/>
+                <a:spcPts val="1800"/>
               </a:spcBef>
               <a:buNone/>
             </a:pPr>
             <a:r>
-              <a:rPr lang="vi" sz="1800" b="1" dirty="0">
-                <a:solidFill>
-                  <a:schemeClr val="accent3"/>
-                </a:solidFill>
-                <a:latin typeface="+mn-lt"/>
-                <a:ea typeface="+mn-ea"/>
-                <a:cs typeface="+mn-cs"/>
-              </a:rPr>
-              <a:t>Từ chối/sửa:</a:t>
-            </a:r>
-            <a:r>
-              <a:rPr lang="vi" sz="1800" dirty="0">
-                <a:solidFill>
-                  <a:schemeClr val="dk1"/>
-                </a:solidFill>
-                <a:latin typeface="+mn-lt"/>
-                <a:ea typeface="+mn-ea"/>
-                <a:cs typeface="+mn-cs"/>
-              </a:rPr>
-              <a:t> bỏ màu xanh dương, bỏ trường MSSV và email edu</a:t>
+              <a:rPr lang="vi" sz="2400" dirty="0" b="1">
+                <a:solidFill>
+                  <a:srgbClr val="1A56C8"/>
+                </a:solidFill>
+                <a:latin typeface="+mn-lt"/>
+                <a:ea typeface="+mn-ea"/>
+                <a:cs typeface="+mn-cs"/>
+              </a:rPr>
+              <a:t>Từ chối: </a:t>
+            </a:r>
+            <a:r>
+              <a:rPr lang="vi" sz="2400" dirty="0">
+                <a:solidFill>
+                  <a:srgbClr val="1C1B18"/>
+                </a:solidFill>
+                <a:latin typeface="+mn-lt"/>
+                <a:ea typeface="+mn-ea"/>
+                <a:cs typeface="+mn-cs"/>
+              </a:rPr>
+              <a:t>tông xanh dương, trường MSSV, email edu</a:t>
             </a:r>
           </a:p>
           <a:p>
             <a:pPr marL="0" indent="0" algn="l">
               <a:lnSpc>
-                <a:spcPts val="2550"/>
+                <a:spcPts val="3240"/>
               </a:lnSpc>
               <a:spcBef>
-                <a:spcPts val="2100"/>
+                <a:spcPts val="1800"/>
               </a:spcBef>
               <a:buNone/>
             </a:pPr>
             <a:r>
-              <a:rPr lang="vi" sz="1800" dirty="0">
-                <a:solidFill>
-                  <a:schemeClr val="dk1"/>
-                </a:solidFill>
-                <a:latin typeface="+mn-lt"/>
-                <a:ea typeface="+mn-ea"/>
-                <a:cs typeface="+mn-cs"/>
-              </a:rPr>
-              <a:t>Mỗi quyết định gắn với một thay đổi trong Figma </a:t>
-            </a:r>
-            <a:r>
-              <a:rPr lang="vi" sz="1800" dirty="0">
-                <a:solidFill>
-                  <a:schemeClr val="dk1"/>
-                </a:solidFill>
-                <a:latin typeface="+mn-lt"/>
-                <a:ea typeface="+mn-ea"/>
-                <a:cs typeface="+mn-cs"/>
-              </a:rPr>
-              <a:t>(vd: S4 và S17 sửa trong Figma; S13 đổi thành "Tutor Match, 6 of 6")</a:t>
+              <a:rPr lang="vi" sz="2400" dirty="0" b="1">
+                <a:solidFill>
+                  <a:srgbClr val="1A56C8"/>
+                </a:solidFill>
+                <a:latin typeface="+mn-lt"/>
+                <a:ea typeface="+mn-ea"/>
+                <a:cs typeface="+mn-cs"/>
+              </a:rPr>
+              <a:t>Thêm (14/10): </a:t>
+            </a:r>
+            <a:r>
+              <a:rPr lang="vi" sz="2400" dirty="0">
+                <a:solidFill>
+                  <a:srgbClr val="1C1B18"/>
+                </a:solidFill>
+                <a:latin typeface="+mn-lt"/>
+                <a:ea typeface="+mn-ea"/>
+                <a:cs typeface="+mn-cs"/>
+              </a:rPr>
+              <a:t>nhập lớp, bỏ thành viên, chặn duyệt khi dưới 5 người (S22-S25)</a:t>
             </a:r>
           </a:p>
         </p:txBody>
@@ -6786,7 +6372,7 @@
               <a:avLst/>
             </a:prstGeom>
             <a:solidFill>
-              <a:schemeClr val="accent3"/>
+              <a:srgbClr val="1A56C8"/>
             </a:solidFill>
             <a:ln>
               <a:noFill/>
@@ -6842,9 +6428,9 @@
             <a:p>
               <a:pPr algn="l"/>
               <a:r>
-                <a:rPr lang="vi" sz="1350" dirty="0">
+                <a:rPr lang="vi" sz="1200" dirty="0">
                   <a:solidFill>
-                    <a:schemeClr val="accent6"/>
+                    <a:srgbClr val="555555"/>
                   </a:solidFill>
                   <a:latin typeface="+mn-lt"/>
                   <a:ea typeface="+mn-ea"/>
@@ -6950,7 +6536,7 @@
         <p:spPr>
           <a:xfrm>
             <a:off x="752856" y="1422400"/>
-            <a:ext cx="4007724" cy="2828544"/>
+            <a:ext cx="5600000" cy="4000000"/>
           </a:xfrm>
           <a:prstGeom prst="rect">
             <a:avLst/>
@@ -6961,126 +6547,104 @@
           </a:ln>
         </p:spPr>
         <p:txBody>
-          <a:bodyPr wrap="none" lIns="0" tIns="0" rIns="0" bIns="0" anchor="t" anchorCtr="0">
+          <a:bodyPr wrap="square" lIns="0" tIns="0" rIns="0" bIns="0" anchor="t" anchorCtr="0">
             <a:noAutofit/>
           </a:bodyPr>
           <a:lstStyle/>
           <a:p>
             <a:pPr marL="0" indent="0" algn="l">
               <a:lnSpc>
-                <a:spcPts val="2550"/>
+                <a:spcPts val="2700"/>
               </a:lnSpc>
               <a:buNone/>
             </a:pPr>
             <a:r>
-              <a:rPr lang="vi" sz="1800" dirty="0">
-                <a:solidFill>
-                  <a:schemeClr val="dk1"/>
-                </a:solidFill>
-                <a:latin typeface="+mn-lt"/>
-                <a:ea typeface="+mn-ea"/>
-                <a:cs typeface="+mn-cs"/>
-              </a:rPr>
-              <a:t>Wireframe thấp (Figma Page 02) so với </a:t>
-            </a:r>
-            <a:r>
-              <a:rPr lang="vi" sz="1800" dirty="0">
-                <a:solidFill>
-                  <a:schemeClr val="dk1"/>
-                </a:solidFill>
-                <a:latin typeface="+mn-lt"/>
-                <a:ea typeface="+mn-ea"/>
-                <a:cs typeface="+mn-cs"/>
-              </a:rPr>
-              <a:t>25 màn final (Page 03, 360×800)</a:t>
+              <a:rPr lang="vi" sz="2000" dirty="0">
+                <a:solidFill>
+                  <a:srgbClr val="1C1B18"/>
+                </a:solidFill>
+                <a:latin typeface="+mn-lt"/>
+                <a:ea typeface="+mn-ea"/>
+                <a:cs typeface="+mn-cs"/>
+              </a:rPr>
+              <a:t>Wireframe (Page 02) → Final UI (Page 03): 25 màn, 360×800</a:t>
             </a:r>
           </a:p>
           <a:p>
             <a:pPr marL="0" indent="0" algn="l">
               <a:lnSpc>
-                <a:spcPts val="2550"/>
+                <a:spcPts val="2700"/>
               </a:lnSpc>
               <a:spcBef>
-                <a:spcPts val="2100"/>
+                <a:spcPts val="1600"/>
               </a:spcBef>
               <a:buNone/>
             </a:pPr>
             <a:r>
-              <a:rPr lang="vi" sz="1800" dirty="0">
-                <a:solidFill>
-                  <a:schemeClr val="dk1"/>
-                </a:solidFill>
-                <a:latin typeface="+mn-lt"/>
-                <a:ea typeface="+mn-ea"/>
-                <a:cs typeface="+mn-cs"/>
-              </a:rPr>
-              <a:t>Một nút chính mỗi màn, </a:t>
-            </a:r>
-            <a:r>
-              <a:rPr lang="vi" sz="1800" dirty="0">
-                <a:solidFill>
-                  <a:schemeClr val="dk1"/>
-                </a:solidFill>
-                <a:latin typeface="+mn-lt"/>
-                <a:ea typeface="+mn-ea"/>
-                <a:cs typeface="+mn-cs"/>
-              </a:rPr>
-              <a:t>hàng ngành 40/48 dp làm điểm nhấn</a:t>
+              <a:rPr lang="vi" sz="2000" dirty="0">
+                <a:solidFill>
+                  <a:srgbClr val="1C1B18"/>
+                </a:solidFill>
+                <a:latin typeface="+mn-lt"/>
+                <a:ea typeface="+mn-ea"/>
+                <a:cs typeface="+mn-cs"/>
+              </a:rPr>
+              <a:t>Một nút chính mỗi màn</a:t>
             </a:r>
           </a:p>
           <a:p>
             <a:pPr marL="0" indent="0" algn="l">
               <a:lnSpc>
-                <a:spcPts val="2550"/>
+                <a:spcPts val="2700"/>
               </a:lnSpc>
               <a:spcBef>
-                <a:spcPts val="2100"/>
+                <a:spcPts val="1600"/>
               </a:spcBef>
               <a:buNone/>
             </a:pPr>
             <a:r>
-              <a:rPr lang="vi" sz="1800" b="1" dirty="0">
-                <a:solidFill>
-                  <a:schemeClr val="dk1"/>
-                </a:solidFill>
-                <a:latin typeface="+mn-lt"/>
-                <a:ea typeface="+mn-ea"/>
-                <a:cs typeface="+mn-cs"/>
-              </a:rPr>
-              <a:t>State:</a:t>
-            </a:r>
-            <a:r>
-              <a:rPr lang="vi" sz="1800" dirty="0">
-                <a:solidFill>
-                  <a:schemeClr val="dk1"/>
-                </a:solidFill>
-                <a:latin typeface="+mn-lt"/>
-                <a:ea typeface="+mn-ea"/>
-                <a:cs typeface="+mn-cs"/>
-              </a:rPr>
-              <a:t> loading (S8), </a:t>
-            </a:r>
-            <a:r>
-              <a:rPr lang="vi" sz="1800" dirty="0">
-                <a:solidFill>
-                  <a:schemeClr val="dk1"/>
-                </a:solidFill>
-                <a:latin typeface="+mn-lt"/>
-                <a:ea typeface="+mn-ea"/>
-                <a:cs typeface="+mn-cs"/>
-              </a:rPr>
-              <a:t>empty (S14 All matched), </a:t>
-            </a:r>
-            <a:r>
-              <a:rPr lang="vi" sz="1800" dirty="0">
-                <a:solidFill>
-                  <a:schemeClr val="dk1"/>
-                </a:solidFill>
-                <a:latin typeface="+mn-lt"/>
-                <a:ea typeface="+mn-ea"/>
-                <a:cs typeface="+mn-cs"/>
-              </a:rPr>
-              <a:t>error (S13, S18), dialog (S12, S17)</a:t>
+              <a:rPr lang="vi" sz="2000" dirty="0">
+                <a:solidFill>
+                  <a:srgbClr val="1C1B18"/>
+                </a:solidFill>
+                <a:latin typeface="+mn-lt"/>
+                <a:ea typeface="+mn-ea"/>
+                <a:cs typeface="+mn-cs"/>
+              </a:rPr>
+              <a:t>Hàng ngành 40/48 dp làm điểm nhấn</a:t>
+            </a:r>
+          </a:p>
+          <a:p>
+            <a:pPr marL="0" indent="0" algn="l">
+              <a:lnSpc>
+                <a:spcPts val="2700"/>
+              </a:lnSpc>
+              <a:spcBef>
+                <a:spcPts val="1600"/>
+              </a:spcBef>
+              <a:buNone/>
+            </a:pPr>
+            <a:r>
+              <a:rPr lang="vi" sz="2000" dirty="0" b="1">
+                <a:solidFill>
+                  <a:srgbClr val="1A56C8"/>
+                </a:solidFill>
+                <a:latin typeface="+mn-lt"/>
+                <a:ea typeface="+mn-ea"/>
+                <a:cs typeface="+mn-cs"/>
+              </a:rPr>
+              <a:t>Trạng thái: </a:t>
+            </a:r>
+            <a:r>
+              <a:rPr lang="vi" sz="2000" dirty="0">
+                <a:solidFill>
+                  <a:srgbClr val="1C1B18"/>
+                </a:solidFill>
+                <a:latin typeface="+mn-lt"/>
+                <a:ea typeface="+mn-ea"/>
+                <a:cs typeface="+mn-cs"/>
+              </a:rPr>
+              <a:t>loading S8, rỗng S14, lỗi S13/S18, dialog S12/S17/S24</a:t>
             </a:r>
           </a:p>
         </p:txBody>
@@ -7231,7 +6795,7 @@
               <a:avLst/>
             </a:prstGeom>
             <a:solidFill>
-              <a:schemeClr val="accent2"/>
+              <a:srgbClr val="1A56C8"/>
             </a:solidFill>
             <a:ln>
               <a:noFill/>
@@ -7287,9 +6851,9 @@
             <a:p>
               <a:pPr algn="l"/>
               <a:r>
-                <a:rPr lang="vi" sz="1350" dirty="0">
+                <a:rPr lang="vi" sz="1200" dirty="0">
                   <a:solidFill>
-                    <a:schemeClr val="accent6"/>
+                    <a:srgbClr val="555555"/>
                   </a:solidFill>
                   <a:latin typeface="+mn-lt"/>
                   <a:ea typeface="+mn-ea"/>
@@ -7310,7 +6874,7 @@
           <p:nvPr/>
         </p:nvPicPr>
         <p:blipFill>
-          <a:blip r:embed="rId4"/>
+          <a:blip r:embed="rId5"/>
           <a:stretch>
             <a:fillRect/>
           </a:stretch>
@@ -7318,7 +6882,7 @@
         <p:spPr>
           <a:xfrm>
             <a:off x="7146302" y="1874519"/>
-            <a:ext cx="2852395" cy="3108959"/>
+            <a:ext cx="2852395" cy="3083670"/>
           </a:xfrm>
           <a:prstGeom prst="rect">
             <a:avLst/>
@@ -7419,7 +6983,7 @@
         <p:spPr>
           <a:xfrm>
             <a:off x="752856" y="1352550"/>
-            <a:ext cx="4174327" cy="4695444"/>
+            <a:ext cx="5600000" cy="4400000"/>
           </a:xfrm>
           <a:prstGeom prst="rect">
             <a:avLst/>
@@ -7430,247 +6994,170 @@
           </a:ln>
         </p:spPr>
         <p:txBody>
-          <a:bodyPr wrap="none" lIns="0" tIns="0" rIns="0" bIns="0" anchor="t" anchorCtr="0">
+          <a:bodyPr wrap="square" lIns="0" tIns="0" rIns="0" bIns="0" anchor="t" anchorCtr="0">
             <a:noAutofit/>
           </a:bodyPr>
           <a:lstStyle/>
           <a:p>
             <a:pPr marL="0" indent="0" algn="l">
               <a:lnSpc>
-                <a:spcPts val="2400"/>
+                <a:spcPts val="2700"/>
               </a:lnSpc>
               <a:buNone/>
             </a:pPr>
             <a:r>
-              <a:rPr lang="vi" sz="1600" b="1" dirty="0">
-                <a:solidFill>
-                  <a:schemeClr val="dk1"/>
-                </a:solidFill>
-                <a:latin typeface="+mn-lt"/>
-                <a:ea typeface="+mn-ea"/>
-                <a:cs typeface="+mn-cs"/>
-              </a:rPr>
-              <a:t>Token màu:</a:t>
-            </a:r>
-            <a:r>
-              <a:rPr lang="vi" sz="1600" dirty="0">
-                <a:solidFill>
-                  <a:schemeClr val="dk1"/>
-                </a:solidFill>
-                <a:latin typeface="+mn-lt"/>
-                <a:ea typeface="+mn-ea"/>
-                <a:cs typeface="+mn-cs"/>
-              </a:rPr>
-              <a:t> primary #B23E00, </a:t>
-            </a:r>
-            <a:r>
-              <a:rPr lang="vi" sz="1600" dirty="0">
-                <a:solidFill>
-                  <a:schemeClr val="dk1"/>
-                </a:solidFill>
-                <a:latin typeface="+mn-lt"/>
-                <a:ea typeface="+mn-ea"/>
-                <a:cs typeface="+mn-cs"/>
-              </a:rPr>
-              <a:t>primary-container #FFE2D2, </a:t>
-            </a:r>
-            <a:r>
-              <a:rPr lang="vi" sz="1600" dirty="0">
-                <a:solidFill>
-                  <a:schemeClr val="dk1"/>
-                </a:solidFill>
-                <a:latin typeface="+mn-lt"/>
-                <a:ea typeface="+mn-ea"/>
-                <a:cs typeface="+mn-cs"/>
-              </a:rPr>
-              <a:t>tertiary #1B6B3C, error #B3261E, </a:t>
-            </a:r>
-            <a:r>
-              <a:rPr lang="vi" sz="1600" dirty="0">
-                <a:solidFill>
-                  <a:schemeClr val="dk1"/>
-                </a:solidFill>
-                <a:latin typeface="+mn-lt"/>
-                <a:ea typeface="+mn-ea"/>
-                <a:cs typeface="+mn-cs"/>
-              </a:rPr>
-              <a:t>surface #FFFFFF, on-surface #1C1B18</a:t>
+              <a:rPr lang="vi" sz="2000" dirty="0" b="1">
+                <a:solidFill>
+                  <a:srgbClr val="1A56C8"/>
+                </a:solidFill>
+                <a:latin typeface="+mn-lt"/>
+                <a:ea typeface="+mn-ea"/>
+                <a:cs typeface="+mn-cs"/>
+              </a:rPr>
+              <a:t>Màu: </a:t>
+            </a:r>
+            <a:r>
+              <a:rPr lang="vi" sz="2000" dirty="0">
+                <a:solidFill>
+                  <a:srgbClr val="1C1B18"/>
+                </a:solidFill>
+                <a:latin typeface="+mn-lt"/>
+                <a:ea typeface="+mn-ea"/>
+                <a:cs typeface="+mn-cs"/>
+              </a:rPr>
+              <a:t>chủ đạo #B23E00, thành công #1B6B3C, lỗi #B3261E</a:t>
             </a:r>
           </a:p>
           <a:p>
             <a:pPr marL="0" indent="0" algn="l">
               <a:lnSpc>
-                <a:spcPts val="2400"/>
+                <a:spcPts val="2700"/>
               </a:lnSpc>
               <a:spcBef>
-                <a:spcPts val="750"/>
+                <a:spcPts val="1600"/>
               </a:spcBef>
               <a:buNone/>
             </a:pPr>
             <a:r>
-              <a:rPr lang="vi" sz="1600" b="1" dirty="0">
-                <a:solidFill>
-                  <a:schemeClr val="dk1"/>
-                </a:solidFill>
-                <a:latin typeface="+mn-lt"/>
-                <a:ea typeface="+mn-ea"/>
-                <a:cs typeface="+mn-cs"/>
-              </a:rPr>
-              <a:t>Chữ:</a:t>
-            </a:r>
-            <a:r>
-              <a:rPr lang="vi" sz="1600" dirty="0">
-                <a:solidFill>
-                  <a:schemeClr val="dk1"/>
-                </a:solidFill>
-                <a:latin typeface="+mn-lt"/>
-                <a:ea typeface="+mn-ea"/>
-                <a:cs typeface="+mn-cs"/>
-              </a:rPr>
-              <a:t> Be Vietnam Pro; </a:t>
-            </a:r>
-            <a:r>
-              <a:rPr lang="vi" sz="1600" dirty="0">
-                <a:solidFill>
-                  <a:schemeClr val="dk1"/>
-                </a:solidFill>
-                <a:latin typeface="+mn-lt"/>
-                <a:ea typeface="+mn-ea"/>
-                <a:cs typeface="+mn-cs"/>
-              </a:rPr>
-              <a:t>6 style (24/20/16/16/14/14 sp)</a:t>
+              <a:rPr lang="vi" sz="2000" dirty="0" b="1">
+                <a:solidFill>
+                  <a:srgbClr val="1A56C8"/>
+                </a:solidFill>
+                <a:latin typeface="+mn-lt"/>
+                <a:ea typeface="+mn-ea"/>
+                <a:cs typeface="+mn-cs"/>
+              </a:rPr>
+              <a:t>Chữ: </a:t>
+            </a:r>
+            <a:r>
+              <a:rPr lang="vi" sz="2000" dirty="0">
+                <a:solidFill>
+                  <a:srgbClr val="1C1B18"/>
+                </a:solidFill>
+                <a:latin typeface="+mn-lt"/>
+                <a:ea typeface="+mn-ea"/>
+                <a:cs typeface="+mn-cs"/>
+              </a:rPr>
+              <a:t>Be Vietnam Pro, 6 style (14-24 sp)</a:t>
             </a:r>
           </a:p>
           <a:p>
             <a:pPr marL="0" indent="0" algn="l">
               <a:lnSpc>
-                <a:spcPts val="2400"/>
+                <a:spcPts val="2700"/>
               </a:lnSpc>
               <a:spcBef>
-                <a:spcPts val="750"/>
+                <a:spcPts val="1600"/>
               </a:spcBef>
               <a:buNone/>
             </a:pPr>
             <a:r>
-              <a:rPr lang="vi" sz="1600" dirty="0">
-                <a:solidFill>
-                  <a:schemeClr val="dk1"/>
-                </a:solidFill>
-                <a:latin typeface="+mn-lt"/>
-                <a:ea typeface="+mn-ea"/>
-                <a:cs typeface="+mn-cs"/>
-              </a:rPr>
-              <a:t>Spacing 4/8/16/24/32; radius 8/12/16/full; </a:t>
-            </a:r>
-            <a:r>
-              <a:rPr lang="vi" sz="1600" dirty="0">
-                <a:solidFill>
-                  <a:schemeClr val="dk1"/>
-                </a:solidFill>
-                <a:latin typeface="+mn-lt"/>
-                <a:ea typeface="+mn-ea"/>
-                <a:cs typeface="+mn-cs"/>
-              </a:rPr>
-              <a:t>elevation phẳng, chỉ dialog và </a:t>
-            </a:r>
-            <a:r>
-              <a:rPr lang="vi" sz="1600" dirty="0">
-                <a:solidFill>
-                  <a:schemeClr val="dk1"/>
-                </a:solidFill>
-                <a:latin typeface="+mn-lt"/>
-                <a:ea typeface="+mn-ea"/>
-                <a:cs typeface="+mn-cs"/>
-              </a:rPr>
-              <a:t>snackbar có bóng</a:t>
+              <a:rPr lang="vi" sz="2000" dirty="0" b="1">
+                <a:solidFill>
+                  <a:srgbClr val="1A56C8"/>
+                </a:solidFill>
+                <a:latin typeface="+mn-lt"/>
+                <a:ea typeface="+mn-ea"/>
+                <a:cs typeface="+mn-cs"/>
+              </a:rPr>
+              <a:t>Spacing: </a:t>
+            </a:r>
+            <a:r>
+              <a:rPr lang="vi" sz="2000" dirty="0">
+                <a:solidFill>
+                  <a:srgbClr val="1C1B18"/>
+                </a:solidFill>
+                <a:latin typeface="+mn-lt"/>
+                <a:ea typeface="+mn-ea"/>
+                <a:cs typeface="+mn-cs"/>
+              </a:rPr>
+              <a:t>4/8/16/24/32; radius 8/12/16/full</a:t>
             </a:r>
           </a:p>
           <a:p>
             <a:pPr marL="0" indent="0" algn="l">
               <a:lnSpc>
-                <a:spcPts val="2400"/>
+                <a:spcPts val="2700"/>
               </a:lnSpc>
               <a:spcBef>
-                <a:spcPts val="750"/>
+                <a:spcPts val="1600"/>
               </a:spcBef>
               <a:buNone/>
             </a:pPr>
             <a:r>
-              <a:rPr lang="vi" sz="1600" b="1" dirty="0">
-                <a:solidFill>
-                  <a:schemeClr val="dk1"/>
-                </a:solidFill>
-                <a:latin typeface="+mn-lt"/>
-                <a:ea typeface="+mn-ea"/>
-                <a:cs typeface="+mn-cs"/>
-              </a:rPr>
-              <a:t>9 component:</a:t>
-            </a:r>
-            <a:r>
-              <a:rPr lang="vi" sz="1600" dirty="0">
-                <a:solidFill>
-                  <a:schemeClr val="dk1"/>
-                </a:solidFill>
-                <a:latin typeface="+mn-lt"/>
-                <a:ea typeface="+mn-ea"/>
-                <a:cs typeface="+mn-cs"/>
-              </a:rPr>
-              <a:t> Button, Text field, </a:t>
-            </a:r>
-            <a:r>
-              <a:rPr lang="vi" sz="1600" dirty="0">
-                <a:solidFill>
-                  <a:schemeClr val="dk1"/>
-                </a:solidFill>
-                <a:latin typeface="+mn-lt"/>
-                <a:ea typeface="+mn-ea"/>
-                <a:cs typeface="+mn-cs"/>
-              </a:rPr>
-              <a:t>Card, Navigation, App bar, Dialog, </a:t>
-            </a:r>
-            <a:r>
-              <a:rPr lang="vi" sz="1600" dirty="0">
-                <a:solidFill>
-                  <a:schemeClr val="dk1"/>
-                </a:solidFill>
-                <a:latin typeface="+mn-lt"/>
-                <a:ea typeface="+mn-ea"/>
-                <a:cs typeface="+mn-cs"/>
-              </a:rPr>
-              <a:t>Loading, Empty, Error, đều có state</a:t>
+              <a:rPr lang="vi" sz="2000" dirty="0" b="1">
+                <a:solidFill>
+                  <a:srgbClr val="1A56C8"/>
+                </a:solidFill>
+                <a:latin typeface="+mn-lt"/>
+                <a:ea typeface="+mn-ea"/>
+                <a:cs typeface="+mn-cs"/>
+              </a:rPr>
+              <a:t>Component: </a:t>
+            </a:r>
+            <a:r>
+              <a:rPr lang="vi" sz="2000" dirty="0">
+                <a:solidFill>
+                  <a:srgbClr val="1C1B18"/>
+                </a:solidFill>
+                <a:latin typeface="+mn-lt"/>
+                <a:ea typeface="+mn-ea"/>
+                <a:cs typeface="+mn-cs"/>
+              </a:rPr>
+              <a:t>14 bộ có variant và state</a:t>
             </a:r>
           </a:p>
           <a:p>
             <a:pPr marL="0" indent="0" algn="l">
               <a:lnSpc>
-                <a:spcPts val="2400"/>
+                <a:spcPts val="2700"/>
               </a:lnSpc>
               <a:spcBef>
-                <a:spcPts val="750"/>
+                <a:spcPts val="1600"/>
               </a:spcBef>
               <a:buNone/>
             </a:pPr>
             <a:r>
-              <a:rPr lang="vi" sz="1600" dirty="0">
-                <a:solidFill>
-                  <a:schemeClr val="dk1"/>
-                </a:solidFill>
-                <a:latin typeface="+mn-lt"/>
-                <a:ea typeface="+mn-ea"/>
-                <a:cs typeface="+mn-cs"/>
-              </a:rPr>
-              <a:t>Token dùng qua Figma Variables </a:t>
-            </a:r>
-            <a:r>
-              <a:rPr lang="vi" sz="1600" dirty="0">
-                <a:solidFill>
-                  <a:schemeClr val="dk1"/>
-                </a:solidFill>
-                <a:latin typeface="+mn-lt"/>
-                <a:ea typeface="+mn-ea"/>
-                <a:cs typeface="+mn-cs"/>
-              </a:rPr>
-              <a:t>(0 màu thô, 25 màn)</a:t>
+              <a:rPr lang="vi" sz="2000" dirty="0" b="1">
+                <a:solidFill>
+                  <a:srgbClr val="1A56C8"/>
+                </a:solidFill>
+                <a:latin typeface="+mn-lt"/>
+                <a:ea typeface="+mn-ea"/>
+                <a:cs typeface="+mn-cs"/>
+              </a:rPr>
+              <a:t>Variables: </a:t>
+            </a:r>
+            <a:r>
+              <a:rPr lang="vi" sz="2000" dirty="0">
+                <a:solidFill>
+                  <a:srgbClr val="1C1B18"/>
+                </a:solidFill>
+                <a:latin typeface="+mn-lt"/>
+                <a:ea typeface="+mn-ea"/>
+                <a:cs typeface="+mn-cs"/>
+              </a:rPr>
+              <a:t>màu gắn biến ở cả 25 màn</a:t>
             </a:r>
           </a:p>
         </p:txBody>
@@ -7730,7 +7217,7 @@
               <a:avLst/>
             </a:prstGeom>
             <a:solidFill>
-              <a:schemeClr val="accent2"/>
+              <a:srgbClr val="1A56C8"/>
             </a:solidFill>
             <a:ln>
               <a:noFill/>
@@ -7786,9 +7273,9 @@
             <a:p>
               <a:pPr algn="l"/>
               <a:r>
-                <a:rPr lang="vi" sz="1350" dirty="0">
+                <a:rPr lang="vi" sz="1200" dirty="0">
                   <a:solidFill>
-                    <a:schemeClr val="accent6"/>
+                    <a:srgbClr val="555555"/>
                   </a:solidFill>
                   <a:latin typeface="+mn-lt"/>
                   <a:ea typeface="+mn-ea"/>

</xml_diff>